<commit_message>
Blend top banner into a multi-photo crossfade instead of a single image
</commit_message>
<xml_diff>
--- a/images/juno bug logo.pptx
+++ b/images/juno bug logo.pptx
@@ -6,8 +6,9 @@
   </p:sldMasterIdLst>
   <p:sldIdLst>
     <p:sldId id="256" r:id="rId2"/>
-    <p:sldId id="258" r:id="rId3"/>
-    <p:sldId id="257" r:id="rId4"/>
+    <p:sldId id="259" r:id="rId3"/>
+    <p:sldId id="258" r:id="rId4"/>
+    <p:sldId id="257" r:id="rId5"/>
   </p:sldIdLst>
   <p:sldSz cx="12192000" cy="6858000"/>
   <p:notesSz cx="6858000" cy="9144000"/>
@@ -106,6 +107,11 @@
       </a:defRPr>
     </a:lvl9pPr>
   </p:defaultTextStyle>
+  <p:extLst>
+    <p:ext uri="{EFAFB233-063F-42B5-8137-9DF3F51BA10A}">
+      <p15:sldGuideLst xmlns:p15="http://schemas.microsoft.com/office/powerpoint/2012/main"/>
+    </p:ext>
+  </p:extLst>
 </p:presentation>
 </file>
 
@@ -258,7 +264,7 @@
           <a:p>
             <a:fld id="{9B1631A4-210E-4433-975B-A06E388530ED}" type="datetimeFigureOut">
               <a:rPr lang="en-NZ" smtClean="0"/>
-              <a:t>28/07/2026</a:t>
+              <a:t>3/08/2026</a:t>
             </a:fld>
             <a:endParaRPr lang="en-NZ"/>
           </a:p>
@@ -458,7 +464,7 @@
           <a:p>
             <a:fld id="{9B1631A4-210E-4433-975B-A06E388530ED}" type="datetimeFigureOut">
               <a:rPr lang="en-NZ" smtClean="0"/>
-              <a:t>28/07/2026</a:t>
+              <a:t>3/08/2026</a:t>
             </a:fld>
             <a:endParaRPr lang="en-NZ"/>
           </a:p>
@@ -668,7 +674,7 @@
           <a:p>
             <a:fld id="{9B1631A4-210E-4433-975B-A06E388530ED}" type="datetimeFigureOut">
               <a:rPr lang="en-NZ" smtClean="0"/>
-              <a:t>28/07/2026</a:t>
+              <a:t>3/08/2026</a:t>
             </a:fld>
             <a:endParaRPr lang="en-NZ"/>
           </a:p>
@@ -868,7 +874,7 @@
           <a:p>
             <a:fld id="{9B1631A4-210E-4433-975B-A06E388530ED}" type="datetimeFigureOut">
               <a:rPr lang="en-NZ" smtClean="0"/>
-              <a:t>28/07/2026</a:t>
+              <a:t>3/08/2026</a:t>
             </a:fld>
             <a:endParaRPr lang="en-NZ"/>
           </a:p>
@@ -1144,7 +1150,7 @@
           <a:p>
             <a:fld id="{9B1631A4-210E-4433-975B-A06E388530ED}" type="datetimeFigureOut">
               <a:rPr lang="en-NZ" smtClean="0"/>
-              <a:t>28/07/2026</a:t>
+              <a:t>3/08/2026</a:t>
             </a:fld>
             <a:endParaRPr lang="en-NZ"/>
           </a:p>
@@ -1412,7 +1418,7 @@
           <a:p>
             <a:fld id="{9B1631A4-210E-4433-975B-A06E388530ED}" type="datetimeFigureOut">
               <a:rPr lang="en-NZ" smtClean="0"/>
-              <a:t>28/07/2026</a:t>
+              <a:t>3/08/2026</a:t>
             </a:fld>
             <a:endParaRPr lang="en-NZ"/>
           </a:p>
@@ -1827,7 +1833,7 @@
           <a:p>
             <a:fld id="{9B1631A4-210E-4433-975B-A06E388530ED}" type="datetimeFigureOut">
               <a:rPr lang="en-NZ" smtClean="0"/>
-              <a:t>28/07/2026</a:t>
+              <a:t>3/08/2026</a:t>
             </a:fld>
             <a:endParaRPr lang="en-NZ"/>
           </a:p>
@@ -1969,7 +1975,7 @@
           <a:p>
             <a:fld id="{9B1631A4-210E-4433-975B-A06E388530ED}" type="datetimeFigureOut">
               <a:rPr lang="en-NZ" smtClean="0"/>
-              <a:t>28/07/2026</a:t>
+              <a:t>3/08/2026</a:t>
             </a:fld>
             <a:endParaRPr lang="en-NZ"/>
           </a:p>
@@ -2082,7 +2088,7 @@
           <a:p>
             <a:fld id="{9B1631A4-210E-4433-975B-A06E388530ED}" type="datetimeFigureOut">
               <a:rPr lang="en-NZ" smtClean="0"/>
-              <a:t>28/07/2026</a:t>
+              <a:t>3/08/2026</a:t>
             </a:fld>
             <a:endParaRPr lang="en-NZ"/>
           </a:p>
@@ -2395,7 +2401,7 @@
           <a:p>
             <a:fld id="{9B1631A4-210E-4433-975B-A06E388530ED}" type="datetimeFigureOut">
               <a:rPr lang="en-NZ" smtClean="0"/>
-              <a:t>28/07/2026</a:t>
+              <a:t>3/08/2026</a:t>
             </a:fld>
             <a:endParaRPr lang="en-NZ"/>
           </a:p>
@@ -2684,7 +2690,7 @@
           <a:p>
             <a:fld id="{9B1631A4-210E-4433-975B-A06E388530ED}" type="datetimeFigureOut">
               <a:rPr lang="en-NZ" smtClean="0"/>
-              <a:t>28/07/2026</a:t>
+              <a:t>3/08/2026</a:t>
             </a:fld>
             <a:endParaRPr lang="en-NZ"/>
           </a:p>
@@ -2927,7 +2933,7 @@
           <a:p>
             <a:fld id="{9B1631A4-210E-4433-975B-A06E388530ED}" type="datetimeFigureOut">
               <a:rPr lang="en-NZ" smtClean="0"/>
-              <a:t>28/07/2026</a:t>
+              <a:t>3/08/2026</a:t>
             </a:fld>
             <a:endParaRPr lang="en-NZ"/>
           </a:p>
@@ -5954,6 +5960,3684 @@
           <a:chExt cx="0" cy="0"/>
         </a:xfrm>
       </p:grpSpPr>
+      <p:grpSp>
+        <p:nvGrpSpPr>
+          <p:cNvPr id="57" name="Group 56">
+            <a:extLst>
+              <a:ext uri="{FF2B5EF4-FFF2-40B4-BE49-F238E27FC236}">
+                <a16:creationId xmlns:a16="http://schemas.microsoft.com/office/drawing/2014/main" id="{988F41C7-96E9-B1B0-BD1A-2229AF08CA52}"/>
+              </a:ext>
+            </a:extLst>
+          </p:cNvPr>
+          <p:cNvGrpSpPr/>
+          <p:nvPr/>
+        </p:nvGrpSpPr>
+        <p:grpSpPr>
+          <a:xfrm>
+            <a:off x="2997047" y="1438300"/>
+            <a:ext cx="3430714" cy="3810000"/>
+            <a:chOff x="2997047" y="1438300"/>
+            <a:chExt cx="3430714" cy="3810000"/>
+          </a:xfrm>
+        </p:grpSpPr>
+        <p:pic>
+          <p:nvPicPr>
+            <p:cNvPr id="5" name="Picture 4">
+              <a:extLst>
+                <a:ext uri="{FF2B5EF4-FFF2-40B4-BE49-F238E27FC236}">
+                  <a16:creationId xmlns:a16="http://schemas.microsoft.com/office/drawing/2014/main" id="{AC7E09D6-8441-95CB-87F7-9BE8988B88D1}"/>
+                </a:ext>
+              </a:extLst>
+            </p:cNvPr>
+            <p:cNvPicPr>
+              <a:picLocks noChangeAspect="1"/>
+            </p:cNvPicPr>
+            <p:nvPr/>
+          </p:nvPicPr>
+          <p:blipFill>
+            <a:blip r:embed="rId2">
+              <a:extLst>
+                <a:ext uri="{28A0092B-C50C-407E-A947-70E740481C1C}">
+                  <a14:useLocalDpi xmlns:a14="http://schemas.microsoft.com/office/drawing/2010/main" val="0"/>
+                </a:ext>
+              </a:extLst>
+            </a:blip>
+            <a:srcRect l="15788" r="16127"/>
+            <a:stretch>
+              <a:fillRect/>
+            </a:stretch>
+          </p:blipFill>
+          <p:spPr>
+            <a:xfrm>
+              <a:off x="3424072" y="1438300"/>
+              <a:ext cx="2594042" cy="3810000"/>
+            </a:xfrm>
+            <a:prstGeom prst="rect">
+              <a:avLst/>
+            </a:prstGeom>
+          </p:spPr>
+        </p:pic>
+        <p:grpSp>
+          <p:nvGrpSpPr>
+            <p:cNvPr id="41" name="Group 40">
+              <a:extLst>
+                <a:ext uri="{FF2B5EF4-FFF2-40B4-BE49-F238E27FC236}">
+                  <a16:creationId xmlns:a16="http://schemas.microsoft.com/office/drawing/2014/main" id="{B54CDE45-AA30-46C0-812D-E089F7441D8C}"/>
+                </a:ext>
+              </a:extLst>
+            </p:cNvPr>
+            <p:cNvGrpSpPr/>
+            <p:nvPr/>
+          </p:nvGrpSpPr>
+          <p:grpSpPr>
+            <a:xfrm>
+              <a:off x="5677461" y="2176091"/>
+              <a:ext cx="750300" cy="2737251"/>
+              <a:chOff x="5677461" y="2176091"/>
+              <a:chExt cx="750300" cy="2737251"/>
+            </a:xfrm>
+          </p:grpSpPr>
+          <p:sp>
+            <p:nvSpPr>
+              <p:cNvPr id="9" name="Oval 15">
+                <a:extLst>
+                  <a:ext uri="{FF2B5EF4-FFF2-40B4-BE49-F238E27FC236}">
+                    <a16:creationId xmlns:a16="http://schemas.microsoft.com/office/drawing/2014/main" id="{5F2E84E8-6A21-9898-2478-5E700516272C}"/>
+                  </a:ext>
+                </a:extLst>
+              </p:cNvPr>
+              <p:cNvSpPr/>
+              <p:nvPr/>
+            </p:nvSpPr>
+            <p:spPr>
+              <a:xfrm rot="1439914" flipH="1">
+                <a:off x="5873621" y="3072463"/>
+                <a:ext cx="358584" cy="83907"/>
+              </a:xfrm>
+              <a:custGeom>
+                <a:avLst/>
+                <a:gdLst>
+                  <a:gd name="csX0" fmla="*/ 0 w 525294"/>
+                  <a:gd name="csY0" fmla="*/ 94034 h 188068"/>
+                  <a:gd name="csX1" fmla="*/ 262647 w 525294"/>
+                  <a:gd name="csY1" fmla="*/ 0 h 188068"/>
+                  <a:gd name="csX2" fmla="*/ 525294 w 525294"/>
+                  <a:gd name="csY2" fmla="*/ 94034 h 188068"/>
+                  <a:gd name="csX3" fmla="*/ 262647 w 525294"/>
+                  <a:gd name="csY3" fmla="*/ 188068 h 188068"/>
+                  <a:gd name="csX4" fmla="*/ 0 w 525294"/>
+                  <a:gd name="csY4" fmla="*/ 94034 h 188068"/>
+                  <a:gd name="csX0" fmla="*/ 0 w 623481"/>
+                  <a:gd name="csY0" fmla="*/ 94831 h 189220"/>
+                  <a:gd name="csX1" fmla="*/ 262647 w 623481"/>
+                  <a:gd name="csY1" fmla="*/ 797 h 189220"/>
+                  <a:gd name="csX2" fmla="*/ 623481 w 623481"/>
+                  <a:gd name="csY2" fmla="*/ 65276 h 189220"/>
+                  <a:gd name="csX3" fmla="*/ 262647 w 623481"/>
+                  <a:gd name="csY3" fmla="*/ 188865 h 189220"/>
+                  <a:gd name="csX4" fmla="*/ 0 w 623481"/>
+                  <a:gd name="csY4" fmla="*/ 94831 h 189220"/>
+                </a:gdLst>
+                <a:ahLst/>
+                <a:cxnLst>
+                  <a:cxn ang="0">
+                    <a:pos x="csX0" y="csY0"/>
+                  </a:cxn>
+                  <a:cxn ang="0">
+                    <a:pos x="csX1" y="csY1"/>
+                  </a:cxn>
+                  <a:cxn ang="0">
+                    <a:pos x="csX2" y="csY2"/>
+                  </a:cxn>
+                  <a:cxn ang="0">
+                    <a:pos x="csX3" y="csY3"/>
+                  </a:cxn>
+                  <a:cxn ang="0">
+                    <a:pos x="csX4" y="csY4"/>
+                  </a:cxn>
+                </a:cxnLst>
+                <a:rect l="l" t="t" r="r" b="b"/>
+                <a:pathLst>
+                  <a:path w="623481" h="189220">
+                    <a:moveTo>
+                      <a:pt x="0" y="94831"/>
+                    </a:moveTo>
+                    <a:cubicBezTo>
+                      <a:pt x="0" y="42897"/>
+                      <a:pt x="158734" y="5723"/>
+                      <a:pt x="262647" y="797"/>
+                    </a:cubicBezTo>
+                    <a:cubicBezTo>
+                      <a:pt x="366560" y="-4129"/>
+                      <a:pt x="623481" y="13342"/>
+                      <a:pt x="623481" y="65276"/>
+                    </a:cubicBezTo>
+                    <a:cubicBezTo>
+                      <a:pt x="623481" y="117210"/>
+                      <a:pt x="366560" y="183939"/>
+                      <a:pt x="262647" y="188865"/>
+                    </a:cubicBezTo>
+                    <a:cubicBezTo>
+                      <a:pt x="158734" y="193791"/>
+                      <a:pt x="0" y="146765"/>
+                      <a:pt x="0" y="94831"/>
+                    </a:cubicBezTo>
+                    <a:close/>
+                  </a:path>
+                </a:pathLst>
+              </a:custGeom>
+              <a:solidFill>
+                <a:schemeClr val="accent6">
+                  <a:lumMod val="75000"/>
+                </a:schemeClr>
+              </a:solidFill>
+              <a:ln>
+                <a:solidFill>
+                  <a:schemeClr val="accent6">
+                    <a:lumMod val="75000"/>
+                  </a:schemeClr>
+                </a:solidFill>
+              </a:ln>
+            </p:spPr>
+            <p:style>
+              <a:lnRef idx="2">
+                <a:schemeClr val="accent6">
+                  <a:shade val="15000"/>
+                </a:schemeClr>
+              </a:lnRef>
+              <a:fillRef idx="1">
+                <a:schemeClr val="accent6"/>
+              </a:fillRef>
+              <a:effectRef idx="0">
+                <a:schemeClr val="accent6"/>
+              </a:effectRef>
+              <a:fontRef idx="minor">
+                <a:schemeClr val="lt1"/>
+              </a:fontRef>
+            </p:style>
+            <p:txBody>
+              <a:bodyPr rtlCol="0" anchor="ctr"/>
+              <a:lstStyle/>
+              <a:p>
+                <a:pPr algn="ctr"/>
+                <a:endParaRPr lang="en-NZ"/>
+              </a:p>
+            </p:txBody>
+          </p:sp>
+          <p:sp>
+            <p:nvSpPr>
+              <p:cNvPr id="10" name="Oval 15">
+                <a:extLst>
+                  <a:ext uri="{FF2B5EF4-FFF2-40B4-BE49-F238E27FC236}">
+                    <a16:creationId xmlns:a16="http://schemas.microsoft.com/office/drawing/2014/main" id="{4B48606F-EE2B-D250-BC8F-A8C139DF2424}"/>
+                  </a:ext>
+                </a:extLst>
+              </p:cNvPr>
+              <p:cNvSpPr/>
+              <p:nvPr/>
+            </p:nvSpPr>
+            <p:spPr>
+              <a:xfrm rot="1297676" flipH="1">
+                <a:off x="5677461" y="2648054"/>
+                <a:ext cx="336104" cy="93295"/>
+              </a:xfrm>
+              <a:custGeom>
+                <a:avLst/>
+                <a:gdLst>
+                  <a:gd name="csX0" fmla="*/ 0 w 525294"/>
+                  <a:gd name="csY0" fmla="*/ 94034 h 188068"/>
+                  <a:gd name="csX1" fmla="*/ 262647 w 525294"/>
+                  <a:gd name="csY1" fmla="*/ 0 h 188068"/>
+                  <a:gd name="csX2" fmla="*/ 525294 w 525294"/>
+                  <a:gd name="csY2" fmla="*/ 94034 h 188068"/>
+                  <a:gd name="csX3" fmla="*/ 262647 w 525294"/>
+                  <a:gd name="csY3" fmla="*/ 188068 h 188068"/>
+                  <a:gd name="csX4" fmla="*/ 0 w 525294"/>
+                  <a:gd name="csY4" fmla="*/ 94034 h 188068"/>
+                  <a:gd name="csX0" fmla="*/ 0 w 623481"/>
+                  <a:gd name="csY0" fmla="*/ 94831 h 189220"/>
+                  <a:gd name="csX1" fmla="*/ 262647 w 623481"/>
+                  <a:gd name="csY1" fmla="*/ 797 h 189220"/>
+                  <a:gd name="csX2" fmla="*/ 623481 w 623481"/>
+                  <a:gd name="csY2" fmla="*/ 65276 h 189220"/>
+                  <a:gd name="csX3" fmla="*/ 262647 w 623481"/>
+                  <a:gd name="csY3" fmla="*/ 188865 h 189220"/>
+                  <a:gd name="csX4" fmla="*/ 0 w 623481"/>
+                  <a:gd name="csY4" fmla="*/ 94831 h 189220"/>
+                </a:gdLst>
+                <a:ahLst/>
+                <a:cxnLst>
+                  <a:cxn ang="0">
+                    <a:pos x="csX0" y="csY0"/>
+                  </a:cxn>
+                  <a:cxn ang="0">
+                    <a:pos x="csX1" y="csY1"/>
+                  </a:cxn>
+                  <a:cxn ang="0">
+                    <a:pos x="csX2" y="csY2"/>
+                  </a:cxn>
+                  <a:cxn ang="0">
+                    <a:pos x="csX3" y="csY3"/>
+                  </a:cxn>
+                  <a:cxn ang="0">
+                    <a:pos x="csX4" y="csY4"/>
+                  </a:cxn>
+                </a:cxnLst>
+                <a:rect l="l" t="t" r="r" b="b"/>
+                <a:pathLst>
+                  <a:path w="623481" h="189220">
+                    <a:moveTo>
+                      <a:pt x="0" y="94831"/>
+                    </a:moveTo>
+                    <a:cubicBezTo>
+                      <a:pt x="0" y="42897"/>
+                      <a:pt x="158734" y="5723"/>
+                      <a:pt x="262647" y="797"/>
+                    </a:cubicBezTo>
+                    <a:cubicBezTo>
+                      <a:pt x="366560" y="-4129"/>
+                      <a:pt x="623481" y="13342"/>
+                      <a:pt x="623481" y="65276"/>
+                    </a:cubicBezTo>
+                    <a:cubicBezTo>
+                      <a:pt x="623481" y="117210"/>
+                      <a:pt x="366560" y="183939"/>
+                      <a:pt x="262647" y="188865"/>
+                    </a:cubicBezTo>
+                    <a:cubicBezTo>
+                      <a:pt x="158734" y="193791"/>
+                      <a:pt x="0" y="146765"/>
+                      <a:pt x="0" y="94831"/>
+                    </a:cubicBezTo>
+                    <a:close/>
+                  </a:path>
+                </a:pathLst>
+              </a:custGeom>
+              <a:solidFill>
+                <a:schemeClr val="accent6">
+                  <a:lumMod val="75000"/>
+                </a:schemeClr>
+              </a:solidFill>
+              <a:ln>
+                <a:solidFill>
+                  <a:schemeClr val="accent6">
+                    <a:lumMod val="75000"/>
+                  </a:schemeClr>
+                </a:solidFill>
+              </a:ln>
+            </p:spPr>
+            <p:style>
+              <a:lnRef idx="2">
+                <a:schemeClr val="accent6">
+                  <a:shade val="15000"/>
+                </a:schemeClr>
+              </a:lnRef>
+              <a:fillRef idx="1">
+                <a:schemeClr val="accent6"/>
+              </a:fillRef>
+              <a:effectRef idx="0">
+                <a:schemeClr val="accent6"/>
+              </a:effectRef>
+              <a:fontRef idx="minor">
+                <a:schemeClr val="lt1"/>
+              </a:fontRef>
+            </p:style>
+            <p:txBody>
+              <a:bodyPr rtlCol="0" anchor="ctr"/>
+              <a:lstStyle/>
+              <a:p>
+                <a:pPr algn="ctr"/>
+                <a:endParaRPr lang="en-NZ"/>
+              </a:p>
+            </p:txBody>
+          </p:sp>
+          <p:sp>
+            <p:nvSpPr>
+              <p:cNvPr id="11" name="Oval 15">
+                <a:extLst>
+                  <a:ext uri="{FF2B5EF4-FFF2-40B4-BE49-F238E27FC236}">
+                    <a16:creationId xmlns:a16="http://schemas.microsoft.com/office/drawing/2014/main" id="{D24CD304-9A32-F514-D87D-48B673967EFB}"/>
+                  </a:ext>
+                </a:extLst>
+              </p:cNvPr>
+              <p:cNvSpPr/>
+              <p:nvPr/>
+            </p:nvSpPr>
+            <p:spPr>
+              <a:xfrm rot="16971223">
+                <a:off x="6035007" y="2816575"/>
+                <a:ext cx="428121" cy="76467"/>
+              </a:xfrm>
+              <a:custGeom>
+                <a:avLst/>
+                <a:gdLst>
+                  <a:gd name="csX0" fmla="*/ 0 w 525294"/>
+                  <a:gd name="csY0" fmla="*/ 94034 h 188068"/>
+                  <a:gd name="csX1" fmla="*/ 262647 w 525294"/>
+                  <a:gd name="csY1" fmla="*/ 0 h 188068"/>
+                  <a:gd name="csX2" fmla="*/ 525294 w 525294"/>
+                  <a:gd name="csY2" fmla="*/ 94034 h 188068"/>
+                  <a:gd name="csX3" fmla="*/ 262647 w 525294"/>
+                  <a:gd name="csY3" fmla="*/ 188068 h 188068"/>
+                  <a:gd name="csX4" fmla="*/ 0 w 525294"/>
+                  <a:gd name="csY4" fmla="*/ 94034 h 188068"/>
+                  <a:gd name="csX0" fmla="*/ 0 w 623481"/>
+                  <a:gd name="csY0" fmla="*/ 94831 h 189220"/>
+                  <a:gd name="csX1" fmla="*/ 262647 w 623481"/>
+                  <a:gd name="csY1" fmla="*/ 797 h 189220"/>
+                  <a:gd name="csX2" fmla="*/ 623481 w 623481"/>
+                  <a:gd name="csY2" fmla="*/ 65276 h 189220"/>
+                  <a:gd name="csX3" fmla="*/ 262647 w 623481"/>
+                  <a:gd name="csY3" fmla="*/ 188865 h 189220"/>
+                  <a:gd name="csX4" fmla="*/ 0 w 623481"/>
+                  <a:gd name="csY4" fmla="*/ 94831 h 189220"/>
+                </a:gdLst>
+                <a:ahLst/>
+                <a:cxnLst>
+                  <a:cxn ang="0">
+                    <a:pos x="csX0" y="csY0"/>
+                  </a:cxn>
+                  <a:cxn ang="0">
+                    <a:pos x="csX1" y="csY1"/>
+                  </a:cxn>
+                  <a:cxn ang="0">
+                    <a:pos x="csX2" y="csY2"/>
+                  </a:cxn>
+                  <a:cxn ang="0">
+                    <a:pos x="csX3" y="csY3"/>
+                  </a:cxn>
+                  <a:cxn ang="0">
+                    <a:pos x="csX4" y="csY4"/>
+                  </a:cxn>
+                </a:cxnLst>
+                <a:rect l="l" t="t" r="r" b="b"/>
+                <a:pathLst>
+                  <a:path w="623481" h="189220">
+                    <a:moveTo>
+                      <a:pt x="0" y="94831"/>
+                    </a:moveTo>
+                    <a:cubicBezTo>
+                      <a:pt x="0" y="42897"/>
+                      <a:pt x="158734" y="5723"/>
+                      <a:pt x="262647" y="797"/>
+                    </a:cubicBezTo>
+                    <a:cubicBezTo>
+                      <a:pt x="366560" y="-4129"/>
+                      <a:pt x="623481" y="13342"/>
+                      <a:pt x="623481" y="65276"/>
+                    </a:cubicBezTo>
+                    <a:cubicBezTo>
+                      <a:pt x="623481" y="117210"/>
+                      <a:pt x="366560" y="183939"/>
+                      <a:pt x="262647" y="188865"/>
+                    </a:cubicBezTo>
+                    <a:cubicBezTo>
+                      <a:pt x="158734" y="193791"/>
+                      <a:pt x="0" y="146765"/>
+                      <a:pt x="0" y="94831"/>
+                    </a:cubicBezTo>
+                    <a:close/>
+                  </a:path>
+                </a:pathLst>
+              </a:custGeom>
+              <a:solidFill>
+                <a:schemeClr val="accent6">
+                  <a:lumMod val="75000"/>
+                </a:schemeClr>
+              </a:solidFill>
+              <a:ln>
+                <a:solidFill>
+                  <a:schemeClr val="accent6">
+                    <a:lumMod val="75000"/>
+                  </a:schemeClr>
+                </a:solidFill>
+              </a:ln>
+            </p:spPr>
+            <p:style>
+              <a:lnRef idx="2">
+                <a:schemeClr val="accent6">
+                  <a:shade val="15000"/>
+                </a:schemeClr>
+              </a:lnRef>
+              <a:fillRef idx="1">
+                <a:schemeClr val="accent6"/>
+              </a:fillRef>
+              <a:effectRef idx="0">
+                <a:schemeClr val="accent6"/>
+              </a:effectRef>
+              <a:fontRef idx="minor">
+                <a:schemeClr val="lt1"/>
+              </a:fontRef>
+            </p:style>
+            <p:txBody>
+              <a:bodyPr rtlCol="0" anchor="ctr"/>
+              <a:lstStyle/>
+              <a:p>
+                <a:pPr algn="ctr"/>
+                <a:endParaRPr lang="en-NZ"/>
+              </a:p>
+            </p:txBody>
+          </p:sp>
+          <p:sp>
+            <p:nvSpPr>
+              <p:cNvPr id="12" name="Oval 15">
+                <a:extLst>
+                  <a:ext uri="{FF2B5EF4-FFF2-40B4-BE49-F238E27FC236}">
+                    <a16:creationId xmlns:a16="http://schemas.microsoft.com/office/drawing/2014/main" id="{D7D3338A-C6EE-D5B4-014C-2B4D81442A74}"/>
+                  </a:ext>
+                </a:extLst>
+              </p:cNvPr>
+              <p:cNvSpPr/>
+              <p:nvPr/>
+            </p:nvSpPr>
+            <p:spPr>
+              <a:xfrm rot="16672422">
+                <a:off x="5925138" y="2645257"/>
+                <a:ext cx="384004" cy="76570"/>
+              </a:xfrm>
+              <a:custGeom>
+                <a:avLst/>
+                <a:gdLst>
+                  <a:gd name="csX0" fmla="*/ 0 w 525294"/>
+                  <a:gd name="csY0" fmla="*/ 94034 h 188068"/>
+                  <a:gd name="csX1" fmla="*/ 262647 w 525294"/>
+                  <a:gd name="csY1" fmla="*/ 0 h 188068"/>
+                  <a:gd name="csX2" fmla="*/ 525294 w 525294"/>
+                  <a:gd name="csY2" fmla="*/ 94034 h 188068"/>
+                  <a:gd name="csX3" fmla="*/ 262647 w 525294"/>
+                  <a:gd name="csY3" fmla="*/ 188068 h 188068"/>
+                  <a:gd name="csX4" fmla="*/ 0 w 525294"/>
+                  <a:gd name="csY4" fmla="*/ 94034 h 188068"/>
+                  <a:gd name="csX0" fmla="*/ 0 w 623481"/>
+                  <a:gd name="csY0" fmla="*/ 94831 h 189220"/>
+                  <a:gd name="csX1" fmla="*/ 262647 w 623481"/>
+                  <a:gd name="csY1" fmla="*/ 797 h 189220"/>
+                  <a:gd name="csX2" fmla="*/ 623481 w 623481"/>
+                  <a:gd name="csY2" fmla="*/ 65276 h 189220"/>
+                  <a:gd name="csX3" fmla="*/ 262647 w 623481"/>
+                  <a:gd name="csY3" fmla="*/ 188865 h 189220"/>
+                  <a:gd name="csX4" fmla="*/ 0 w 623481"/>
+                  <a:gd name="csY4" fmla="*/ 94831 h 189220"/>
+                </a:gdLst>
+                <a:ahLst/>
+                <a:cxnLst>
+                  <a:cxn ang="0">
+                    <a:pos x="csX0" y="csY0"/>
+                  </a:cxn>
+                  <a:cxn ang="0">
+                    <a:pos x="csX1" y="csY1"/>
+                  </a:cxn>
+                  <a:cxn ang="0">
+                    <a:pos x="csX2" y="csY2"/>
+                  </a:cxn>
+                  <a:cxn ang="0">
+                    <a:pos x="csX3" y="csY3"/>
+                  </a:cxn>
+                  <a:cxn ang="0">
+                    <a:pos x="csX4" y="csY4"/>
+                  </a:cxn>
+                </a:cxnLst>
+                <a:rect l="l" t="t" r="r" b="b"/>
+                <a:pathLst>
+                  <a:path w="623481" h="189220">
+                    <a:moveTo>
+                      <a:pt x="0" y="94831"/>
+                    </a:moveTo>
+                    <a:cubicBezTo>
+                      <a:pt x="0" y="42897"/>
+                      <a:pt x="158734" y="5723"/>
+                      <a:pt x="262647" y="797"/>
+                    </a:cubicBezTo>
+                    <a:cubicBezTo>
+                      <a:pt x="366560" y="-4129"/>
+                      <a:pt x="623481" y="13342"/>
+                      <a:pt x="623481" y="65276"/>
+                    </a:cubicBezTo>
+                    <a:cubicBezTo>
+                      <a:pt x="623481" y="117210"/>
+                      <a:pt x="366560" y="183939"/>
+                      <a:pt x="262647" y="188865"/>
+                    </a:cubicBezTo>
+                    <a:cubicBezTo>
+                      <a:pt x="158734" y="193791"/>
+                      <a:pt x="0" y="146765"/>
+                      <a:pt x="0" y="94831"/>
+                    </a:cubicBezTo>
+                    <a:close/>
+                  </a:path>
+                </a:pathLst>
+              </a:custGeom>
+              <a:solidFill>
+                <a:schemeClr val="accent6">
+                  <a:lumMod val="75000"/>
+                </a:schemeClr>
+              </a:solidFill>
+              <a:ln>
+                <a:solidFill>
+                  <a:schemeClr val="accent6">
+                    <a:lumMod val="75000"/>
+                  </a:schemeClr>
+                </a:solidFill>
+              </a:ln>
+            </p:spPr>
+            <p:style>
+              <a:lnRef idx="2">
+                <a:schemeClr val="accent6">
+                  <a:shade val="15000"/>
+                </a:schemeClr>
+              </a:lnRef>
+              <a:fillRef idx="1">
+                <a:schemeClr val="accent6"/>
+              </a:fillRef>
+              <a:effectRef idx="0">
+                <a:schemeClr val="accent6"/>
+              </a:effectRef>
+              <a:fontRef idx="minor">
+                <a:schemeClr val="lt1"/>
+              </a:fontRef>
+            </p:style>
+            <p:txBody>
+              <a:bodyPr rtlCol="0" anchor="ctr"/>
+              <a:lstStyle/>
+              <a:p>
+                <a:pPr algn="ctr"/>
+                <a:endParaRPr lang="en-NZ"/>
+              </a:p>
+            </p:txBody>
+          </p:sp>
+          <p:sp>
+            <p:nvSpPr>
+              <p:cNvPr id="13" name="Oval 15">
+                <a:extLst>
+                  <a:ext uri="{FF2B5EF4-FFF2-40B4-BE49-F238E27FC236}">
+                    <a16:creationId xmlns:a16="http://schemas.microsoft.com/office/drawing/2014/main" id="{307DDED2-445E-4E5F-B7FC-333245FB2F1F}"/>
+                  </a:ext>
+                </a:extLst>
+              </p:cNvPr>
+              <p:cNvSpPr/>
+              <p:nvPr/>
+            </p:nvSpPr>
+            <p:spPr>
+              <a:xfrm rot="14162025">
+                <a:off x="5581911" y="2324390"/>
+                <a:ext cx="367317" cy="70720"/>
+              </a:xfrm>
+              <a:custGeom>
+                <a:avLst/>
+                <a:gdLst>
+                  <a:gd name="csX0" fmla="*/ 0 w 525294"/>
+                  <a:gd name="csY0" fmla="*/ 94034 h 188068"/>
+                  <a:gd name="csX1" fmla="*/ 262647 w 525294"/>
+                  <a:gd name="csY1" fmla="*/ 0 h 188068"/>
+                  <a:gd name="csX2" fmla="*/ 525294 w 525294"/>
+                  <a:gd name="csY2" fmla="*/ 94034 h 188068"/>
+                  <a:gd name="csX3" fmla="*/ 262647 w 525294"/>
+                  <a:gd name="csY3" fmla="*/ 188068 h 188068"/>
+                  <a:gd name="csX4" fmla="*/ 0 w 525294"/>
+                  <a:gd name="csY4" fmla="*/ 94034 h 188068"/>
+                  <a:gd name="csX0" fmla="*/ 0 w 623481"/>
+                  <a:gd name="csY0" fmla="*/ 94831 h 189220"/>
+                  <a:gd name="csX1" fmla="*/ 262647 w 623481"/>
+                  <a:gd name="csY1" fmla="*/ 797 h 189220"/>
+                  <a:gd name="csX2" fmla="*/ 623481 w 623481"/>
+                  <a:gd name="csY2" fmla="*/ 65276 h 189220"/>
+                  <a:gd name="csX3" fmla="*/ 262647 w 623481"/>
+                  <a:gd name="csY3" fmla="*/ 188865 h 189220"/>
+                  <a:gd name="csX4" fmla="*/ 0 w 623481"/>
+                  <a:gd name="csY4" fmla="*/ 94831 h 189220"/>
+                </a:gdLst>
+                <a:ahLst/>
+                <a:cxnLst>
+                  <a:cxn ang="0">
+                    <a:pos x="csX0" y="csY0"/>
+                  </a:cxn>
+                  <a:cxn ang="0">
+                    <a:pos x="csX1" y="csY1"/>
+                  </a:cxn>
+                  <a:cxn ang="0">
+                    <a:pos x="csX2" y="csY2"/>
+                  </a:cxn>
+                  <a:cxn ang="0">
+                    <a:pos x="csX3" y="csY3"/>
+                  </a:cxn>
+                  <a:cxn ang="0">
+                    <a:pos x="csX4" y="csY4"/>
+                  </a:cxn>
+                </a:cxnLst>
+                <a:rect l="l" t="t" r="r" b="b"/>
+                <a:pathLst>
+                  <a:path w="623481" h="189220">
+                    <a:moveTo>
+                      <a:pt x="0" y="94831"/>
+                    </a:moveTo>
+                    <a:cubicBezTo>
+                      <a:pt x="0" y="42897"/>
+                      <a:pt x="158734" y="5723"/>
+                      <a:pt x="262647" y="797"/>
+                    </a:cubicBezTo>
+                    <a:cubicBezTo>
+                      <a:pt x="366560" y="-4129"/>
+                      <a:pt x="623481" y="13342"/>
+                      <a:pt x="623481" y="65276"/>
+                    </a:cubicBezTo>
+                    <a:cubicBezTo>
+                      <a:pt x="623481" y="117210"/>
+                      <a:pt x="366560" y="183939"/>
+                      <a:pt x="262647" y="188865"/>
+                    </a:cubicBezTo>
+                    <a:cubicBezTo>
+                      <a:pt x="158734" y="193791"/>
+                      <a:pt x="0" y="146765"/>
+                      <a:pt x="0" y="94831"/>
+                    </a:cubicBezTo>
+                    <a:close/>
+                  </a:path>
+                </a:pathLst>
+              </a:custGeom>
+              <a:solidFill>
+                <a:schemeClr val="accent6">
+                  <a:lumMod val="75000"/>
+                </a:schemeClr>
+              </a:solidFill>
+              <a:ln>
+                <a:solidFill>
+                  <a:schemeClr val="accent6">
+                    <a:lumMod val="75000"/>
+                  </a:schemeClr>
+                </a:solidFill>
+              </a:ln>
+            </p:spPr>
+            <p:style>
+              <a:lnRef idx="2">
+                <a:schemeClr val="accent6">
+                  <a:shade val="15000"/>
+                </a:schemeClr>
+              </a:lnRef>
+              <a:fillRef idx="1">
+                <a:schemeClr val="accent6"/>
+              </a:fillRef>
+              <a:effectRef idx="0">
+                <a:schemeClr val="accent6"/>
+              </a:effectRef>
+              <a:fontRef idx="minor">
+                <a:schemeClr val="lt1"/>
+              </a:fontRef>
+            </p:style>
+            <p:txBody>
+              <a:bodyPr rtlCol="0" anchor="ctr"/>
+              <a:lstStyle/>
+              <a:p>
+                <a:pPr algn="ctr"/>
+                <a:endParaRPr lang="en-NZ"/>
+              </a:p>
+            </p:txBody>
+          </p:sp>
+          <p:sp>
+            <p:nvSpPr>
+              <p:cNvPr id="14" name="Oval 15">
+                <a:extLst>
+                  <a:ext uri="{FF2B5EF4-FFF2-40B4-BE49-F238E27FC236}">
+                    <a16:creationId xmlns:a16="http://schemas.microsoft.com/office/drawing/2014/main" id="{7B5E1C3C-210C-9516-8755-2640F9550CFF}"/>
+                  </a:ext>
+                </a:extLst>
+              </p:cNvPr>
+              <p:cNvSpPr/>
+              <p:nvPr/>
+            </p:nvSpPr>
+            <p:spPr>
+              <a:xfrm rot="2313172" flipH="1">
+                <a:off x="5906204" y="3935761"/>
+                <a:ext cx="368562" cy="86250"/>
+              </a:xfrm>
+              <a:custGeom>
+                <a:avLst/>
+                <a:gdLst>
+                  <a:gd name="csX0" fmla="*/ 0 w 525294"/>
+                  <a:gd name="csY0" fmla="*/ 94034 h 188068"/>
+                  <a:gd name="csX1" fmla="*/ 262647 w 525294"/>
+                  <a:gd name="csY1" fmla="*/ 0 h 188068"/>
+                  <a:gd name="csX2" fmla="*/ 525294 w 525294"/>
+                  <a:gd name="csY2" fmla="*/ 94034 h 188068"/>
+                  <a:gd name="csX3" fmla="*/ 262647 w 525294"/>
+                  <a:gd name="csY3" fmla="*/ 188068 h 188068"/>
+                  <a:gd name="csX4" fmla="*/ 0 w 525294"/>
+                  <a:gd name="csY4" fmla="*/ 94034 h 188068"/>
+                  <a:gd name="csX0" fmla="*/ 0 w 623481"/>
+                  <a:gd name="csY0" fmla="*/ 94831 h 189220"/>
+                  <a:gd name="csX1" fmla="*/ 262647 w 623481"/>
+                  <a:gd name="csY1" fmla="*/ 797 h 189220"/>
+                  <a:gd name="csX2" fmla="*/ 623481 w 623481"/>
+                  <a:gd name="csY2" fmla="*/ 65276 h 189220"/>
+                  <a:gd name="csX3" fmla="*/ 262647 w 623481"/>
+                  <a:gd name="csY3" fmla="*/ 188865 h 189220"/>
+                  <a:gd name="csX4" fmla="*/ 0 w 623481"/>
+                  <a:gd name="csY4" fmla="*/ 94831 h 189220"/>
+                </a:gdLst>
+                <a:ahLst/>
+                <a:cxnLst>
+                  <a:cxn ang="0">
+                    <a:pos x="csX0" y="csY0"/>
+                  </a:cxn>
+                  <a:cxn ang="0">
+                    <a:pos x="csX1" y="csY1"/>
+                  </a:cxn>
+                  <a:cxn ang="0">
+                    <a:pos x="csX2" y="csY2"/>
+                  </a:cxn>
+                  <a:cxn ang="0">
+                    <a:pos x="csX3" y="csY3"/>
+                  </a:cxn>
+                  <a:cxn ang="0">
+                    <a:pos x="csX4" y="csY4"/>
+                  </a:cxn>
+                </a:cxnLst>
+                <a:rect l="l" t="t" r="r" b="b"/>
+                <a:pathLst>
+                  <a:path w="623481" h="189220">
+                    <a:moveTo>
+                      <a:pt x="0" y="94831"/>
+                    </a:moveTo>
+                    <a:cubicBezTo>
+                      <a:pt x="0" y="42897"/>
+                      <a:pt x="158734" y="5723"/>
+                      <a:pt x="262647" y="797"/>
+                    </a:cubicBezTo>
+                    <a:cubicBezTo>
+                      <a:pt x="366560" y="-4129"/>
+                      <a:pt x="623481" y="13342"/>
+                      <a:pt x="623481" y="65276"/>
+                    </a:cubicBezTo>
+                    <a:cubicBezTo>
+                      <a:pt x="623481" y="117210"/>
+                      <a:pt x="366560" y="183939"/>
+                      <a:pt x="262647" y="188865"/>
+                    </a:cubicBezTo>
+                    <a:cubicBezTo>
+                      <a:pt x="158734" y="193791"/>
+                      <a:pt x="0" y="146765"/>
+                      <a:pt x="0" y="94831"/>
+                    </a:cubicBezTo>
+                    <a:close/>
+                  </a:path>
+                </a:pathLst>
+              </a:custGeom>
+              <a:solidFill>
+                <a:schemeClr val="accent6">
+                  <a:lumMod val="75000"/>
+                </a:schemeClr>
+              </a:solidFill>
+              <a:ln>
+                <a:solidFill>
+                  <a:schemeClr val="accent6">
+                    <a:lumMod val="75000"/>
+                  </a:schemeClr>
+                </a:solidFill>
+              </a:ln>
+            </p:spPr>
+            <p:style>
+              <a:lnRef idx="2">
+                <a:schemeClr val="accent6">
+                  <a:shade val="15000"/>
+                </a:schemeClr>
+              </a:lnRef>
+              <a:fillRef idx="1">
+                <a:schemeClr val="accent6"/>
+              </a:fillRef>
+              <a:effectRef idx="0">
+                <a:schemeClr val="accent6"/>
+              </a:effectRef>
+              <a:fontRef idx="minor">
+                <a:schemeClr val="lt1"/>
+              </a:fontRef>
+            </p:style>
+            <p:txBody>
+              <a:bodyPr rtlCol="0" anchor="ctr"/>
+              <a:lstStyle/>
+              <a:p>
+                <a:pPr algn="ctr"/>
+                <a:endParaRPr lang="en-NZ"/>
+              </a:p>
+            </p:txBody>
+          </p:sp>
+          <p:sp>
+            <p:nvSpPr>
+              <p:cNvPr id="16" name="Oval 15">
+                <a:extLst>
+                  <a:ext uri="{FF2B5EF4-FFF2-40B4-BE49-F238E27FC236}">
+                    <a16:creationId xmlns:a16="http://schemas.microsoft.com/office/drawing/2014/main" id="{A87DD1C5-A39D-F682-658F-CCA892157DB1}"/>
+                  </a:ext>
+                </a:extLst>
+              </p:cNvPr>
+              <p:cNvSpPr/>
+              <p:nvPr/>
+            </p:nvSpPr>
+            <p:spPr>
+              <a:xfrm rot="2313172" flipH="1">
+                <a:off x="5988751" y="3323709"/>
+                <a:ext cx="291208" cy="92887"/>
+              </a:xfrm>
+              <a:custGeom>
+                <a:avLst/>
+                <a:gdLst>
+                  <a:gd name="csX0" fmla="*/ 0 w 525294"/>
+                  <a:gd name="csY0" fmla="*/ 94034 h 188068"/>
+                  <a:gd name="csX1" fmla="*/ 262647 w 525294"/>
+                  <a:gd name="csY1" fmla="*/ 0 h 188068"/>
+                  <a:gd name="csX2" fmla="*/ 525294 w 525294"/>
+                  <a:gd name="csY2" fmla="*/ 94034 h 188068"/>
+                  <a:gd name="csX3" fmla="*/ 262647 w 525294"/>
+                  <a:gd name="csY3" fmla="*/ 188068 h 188068"/>
+                  <a:gd name="csX4" fmla="*/ 0 w 525294"/>
+                  <a:gd name="csY4" fmla="*/ 94034 h 188068"/>
+                  <a:gd name="csX0" fmla="*/ 0 w 623481"/>
+                  <a:gd name="csY0" fmla="*/ 94831 h 189220"/>
+                  <a:gd name="csX1" fmla="*/ 262647 w 623481"/>
+                  <a:gd name="csY1" fmla="*/ 797 h 189220"/>
+                  <a:gd name="csX2" fmla="*/ 623481 w 623481"/>
+                  <a:gd name="csY2" fmla="*/ 65276 h 189220"/>
+                  <a:gd name="csX3" fmla="*/ 262647 w 623481"/>
+                  <a:gd name="csY3" fmla="*/ 188865 h 189220"/>
+                  <a:gd name="csX4" fmla="*/ 0 w 623481"/>
+                  <a:gd name="csY4" fmla="*/ 94831 h 189220"/>
+                </a:gdLst>
+                <a:ahLst/>
+                <a:cxnLst>
+                  <a:cxn ang="0">
+                    <a:pos x="csX0" y="csY0"/>
+                  </a:cxn>
+                  <a:cxn ang="0">
+                    <a:pos x="csX1" y="csY1"/>
+                  </a:cxn>
+                  <a:cxn ang="0">
+                    <a:pos x="csX2" y="csY2"/>
+                  </a:cxn>
+                  <a:cxn ang="0">
+                    <a:pos x="csX3" y="csY3"/>
+                  </a:cxn>
+                  <a:cxn ang="0">
+                    <a:pos x="csX4" y="csY4"/>
+                  </a:cxn>
+                </a:cxnLst>
+                <a:rect l="l" t="t" r="r" b="b"/>
+                <a:pathLst>
+                  <a:path w="623481" h="189220">
+                    <a:moveTo>
+                      <a:pt x="0" y="94831"/>
+                    </a:moveTo>
+                    <a:cubicBezTo>
+                      <a:pt x="0" y="42897"/>
+                      <a:pt x="158734" y="5723"/>
+                      <a:pt x="262647" y="797"/>
+                    </a:cubicBezTo>
+                    <a:cubicBezTo>
+                      <a:pt x="366560" y="-4129"/>
+                      <a:pt x="623481" y="13342"/>
+                      <a:pt x="623481" y="65276"/>
+                    </a:cubicBezTo>
+                    <a:cubicBezTo>
+                      <a:pt x="623481" y="117210"/>
+                      <a:pt x="366560" y="183939"/>
+                      <a:pt x="262647" y="188865"/>
+                    </a:cubicBezTo>
+                    <a:cubicBezTo>
+                      <a:pt x="158734" y="193791"/>
+                      <a:pt x="0" y="146765"/>
+                      <a:pt x="0" y="94831"/>
+                    </a:cubicBezTo>
+                    <a:close/>
+                  </a:path>
+                </a:pathLst>
+              </a:custGeom>
+              <a:solidFill>
+                <a:schemeClr val="accent6">
+                  <a:lumMod val="75000"/>
+                </a:schemeClr>
+              </a:solidFill>
+              <a:ln>
+                <a:solidFill>
+                  <a:schemeClr val="accent6">
+                    <a:lumMod val="75000"/>
+                  </a:schemeClr>
+                </a:solidFill>
+              </a:ln>
+            </p:spPr>
+            <p:style>
+              <a:lnRef idx="2">
+                <a:schemeClr val="accent6">
+                  <a:shade val="15000"/>
+                </a:schemeClr>
+              </a:lnRef>
+              <a:fillRef idx="1">
+                <a:schemeClr val="accent6"/>
+              </a:fillRef>
+              <a:effectRef idx="0">
+                <a:schemeClr val="accent6"/>
+              </a:effectRef>
+              <a:fontRef idx="minor">
+                <a:schemeClr val="lt1"/>
+              </a:fontRef>
+            </p:style>
+            <p:txBody>
+              <a:bodyPr rtlCol="0" anchor="ctr"/>
+              <a:lstStyle/>
+              <a:p>
+                <a:pPr algn="ctr"/>
+                <a:endParaRPr lang="en-NZ"/>
+              </a:p>
+            </p:txBody>
+          </p:sp>
+          <p:sp>
+            <p:nvSpPr>
+              <p:cNvPr id="17" name="Oval 15">
+                <a:extLst>
+                  <a:ext uri="{FF2B5EF4-FFF2-40B4-BE49-F238E27FC236}">
+                    <a16:creationId xmlns:a16="http://schemas.microsoft.com/office/drawing/2014/main" id="{933A393D-9973-AA86-FE02-CB612DB39D30}"/>
+                  </a:ext>
+                </a:extLst>
+              </p:cNvPr>
+              <p:cNvSpPr/>
+              <p:nvPr/>
+            </p:nvSpPr>
+            <p:spPr>
+              <a:xfrm rot="17214883">
+                <a:off x="6115209" y="3106268"/>
+                <a:ext cx="428121" cy="76467"/>
+              </a:xfrm>
+              <a:custGeom>
+                <a:avLst/>
+                <a:gdLst>
+                  <a:gd name="csX0" fmla="*/ 0 w 525294"/>
+                  <a:gd name="csY0" fmla="*/ 94034 h 188068"/>
+                  <a:gd name="csX1" fmla="*/ 262647 w 525294"/>
+                  <a:gd name="csY1" fmla="*/ 0 h 188068"/>
+                  <a:gd name="csX2" fmla="*/ 525294 w 525294"/>
+                  <a:gd name="csY2" fmla="*/ 94034 h 188068"/>
+                  <a:gd name="csX3" fmla="*/ 262647 w 525294"/>
+                  <a:gd name="csY3" fmla="*/ 188068 h 188068"/>
+                  <a:gd name="csX4" fmla="*/ 0 w 525294"/>
+                  <a:gd name="csY4" fmla="*/ 94034 h 188068"/>
+                  <a:gd name="csX0" fmla="*/ 0 w 623481"/>
+                  <a:gd name="csY0" fmla="*/ 94831 h 189220"/>
+                  <a:gd name="csX1" fmla="*/ 262647 w 623481"/>
+                  <a:gd name="csY1" fmla="*/ 797 h 189220"/>
+                  <a:gd name="csX2" fmla="*/ 623481 w 623481"/>
+                  <a:gd name="csY2" fmla="*/ 65276 h 189220"/>
+                  <a:gd name="csX3" fmla="*/ 262647 w 623481"/>
+                  <a:gd name="csY3" fmla="*/ 188865 h 189220"/>
+                  <a:gd name="csX4" fmla="*/ 0 w 623481"/>
+                  <a:gd name="csY4" fmla="*/ 94831 h 189220"/>
+                </a:gdLst>
+                <a:ahLst/>
+                <a:cxnLst>
+                  <a:cxn ang="0">
+                    <a:pos x="csX0" y="csY0"/>
+                  </a:cxn>
+                  <a:cxn ang="0">
+                    <a:pos x="csX1" y="csY1"/>
+                  </a:cxn>
+                  <a:cxn ang="0">
+                    <a:pos x="csX2" y="csY2"/>
+                  </a:cxn>
+                  <a:cxn ang="0">
+                    <a:pos x="csX3" y="csY3"/>
+                  </a:cxn>
+                  <a:cxn ang="0">
+                    <a:pos x="csX4" y="csY4"/>
+                  </a:cxn>
+                </a:cxnLst>
+                <a:rect l="l" t="t" r="r" b="b"/>
+                <a:pathLst>
+                  <a:path w="623481" h="189220">
+                    <a:moveTo>
+                      <a:pt x="0" y="94831"/>
+                    </a:moveTo>
+                    <a:cubicBezTo>
+                      <a:pt x="0" y="42897"/>
+                      <a:pt x="158734" y="5723"/>
+                      <a:pt x="262647" y="797"/>
+                    </a:cubicBezTo>
+                    <a:cubicBezTo>
+                      <a:pt x="366560" y="-4129"/>
+                      <a:pt x="623481" y="13342"/>
+                      <a:pt x="623481" y="65276"/>
+                    </a:cubicBezTo>
+                    <a:cubicBezTo>
+                      <a:pt x="623481" y="117210"/>
+                      <a:pt x="366560" y="183939"/>
+                      <a:pt x="262647" y="188865"/>
+                    </a:cubicBezTo>
+                    <a:cubicBezTo>
+                      <a:pt x="158734" y="193791"/>
+                      <a:pt x="0" y="146765"/>
+                      <a:pt x="0" y="94831"/>
+                    </a:cubicBezTo>
+                    <a:close/>
+                  </a:path>
+                </a:pathLst>
+              </a:custGeom>
+              <a:solidFill>
+                <a:schemeClr val="accent6">
+                  <a:lumMod val="75000"/>
+                </a:schemeClr>
+              </a:solidFill>
+              <a:ln>
+                <a:solidFill>
+                  <a:schemeClr val="accent6">
+                    <a:lumMod val="75000"/>
+                  </a:schemeClr>
+                </a:solidFill>
+              </a:ln>
+            </p:spPr>
+            <p:style>
+              <a:lnRef idx="2">
+                <a:schemeClr val="accent6">
+                  <a:shade val="15000"/>
+                </a:schemeClr>
+              </a:lnRef>
+              <a:fillRef idx="1">
+                <a:schemeClr val="accent6"/>
+              </a:fillRef>
+              <a:effectRef idx="0">
+                <a:schemeClr val="accent6"/>
+              </a:effectRef>
+              <a:fontRef idx="minor">
+                <a:schemeClr val="lt1"/>
+              </a:fontRef>
+            </p:style>
+            <p:txBody>
+              <a:bodyPr rtlCol="0" anchor="ctr"/>
+              <a:lstStyle/>
+              <a:p>
+                <a:pPr algn="ctr"/>
+                <a:endParaRPr lang="en-NZ"/>
+              </a:p>
+            </p:txBody>
+          </p:sp>
+          <p:sp>
+            <p:nvSpPr>
+              <p:cNvPr id="30" name="Freeform: Shape 29">
+                <a:extLst>
+                  <a:ext uri="{FF2B5EF4-FFF2-40B4-BE49-F238E27FC236}">
+                    <a16:creationId xmlns:a16="http://schemas.microsoft.com/office/drawing/2014/main" id="{2BACC278-1E5D-65E3-DE6B-73C8F5EAF8E5}"/>
+                  </a:ext>
+                </a:extLst>
+              </p:cNvPr>
+              <p:cNvSpPr/>
+              <p:nvPr/>
+            </p:nvSpPr>
+            <p:spPr>
+              <a:xfrm>
+                <a:off x="5799213" y="2487912"/>
+                <a:ext cx="477954" cy="2425430"/>
+              </a:xfrm>
+              <a:custGeom>
+                <a:avLst/>
+                <a:gdLst>
+                  <a:gd name="csX0" fmla="*/ 32425 w 477954"/>
+                  <a:gd name="csY0" fmla="*/ 0 h 2425430"/>
+                  <a:gd name="csX1" fmla="*/ 239949 w 477954"/>
+                  <a:gd name="csY1" fmla="*/ 272374 h 2425430"/>
+                  <a:gd name="csX2" fmla="*/ 453957 w 477954"/>
+                  <a:gd name="csY2" fmla="*/ 791183 h 2425430"/>
+                  <a:gd name="csX3" fmla="*/ 453957 w 477954"/>
+                  <a:gd name="csY3" fmla="*/ 1543455 h 2425430"/>
+                  <a:gd name="csX4" fmla="*/ 285344 w 477954"/>
+                  <a:gd name="csY4" fmla="*/ 2049293 h 2425430"/>
+                  <a:gd name="csX5" fmla="*/ 0 w 477954"/>
+                  <a:gd name="csY5" fmla="*/ 2425430 h 2425430"/>
+                  <a:gd name="csX6" fmla="*/ 0 w 477954"/>
+                  <a:gd name="csY6" fmla="*/ 2425430 h 2425430"/>
+                </a:gdLst>
+                <a:ahLst/>
+                <a:cxnLst>
+                  <a:cxn ang="0">
+                    <a:pos x="csX0" y="csY0"/>
+                  </a:cxn>
+                  <a:cxn ang="0">
+                    <a:pos x="csX1" y="csY1"/>
+                  </a:cxn>
+                  <a:cxn ang="0">
+                    <a:pos x="csX2" y="csY2"/>
+                  </a:cxn>
+                  <a:cxn ang="0">
+                    <a:pos x="csX3" y="csY3"/>
+                  </a:cxn>
+                  <a:cxn ang="0">
+                    <a:pos x="csX4" y="csY4"/>
+                  </a:cxn>
+                  <a:cxn ang="0">
+                    <a:pos x="csX5" y="csY5"/>
+                  </a:cxn>
+                  <a:cxn ang="0">
+                    <a:pos x="csX6" y="csY6"/>
+                  </a:cxn>
+                </a:cxnLst>
+                <a:rect l="l" t="t" r="r" b="b"/>
+                <a:pathLst>
+                  <a:path w="477954" h="2425430">
+                    <a:moveTo>
+                      <a:pt x="32425" y="0"/>
+                    </a:moveTo>
+                    <a:cubicBezTo>
+                      <a:pt x="101059" y="70255"/>
+                      <a:pt x="169694" y="140510"/>
+                      <a:pt x="239949" y="272374"/>
+                    </a:cubicBezTo>
+                    <a:cubicBezTo>
+                      <a:pt x="310204" y="404238"/>
+                      <a:pt x="418289" y="579336"/>
+                      <a:pt x="453957" y="791183"/>
+                    </a:cubicBezTo>
+                    <a:cubicBezTo>
+                      <a:pt x="489625" y="1003030"/>
+                      <a:pt x="482059" y="1333770"/>
+                      <a:pt x="453957" y="1543455"/>
+                    </a:cubicBezTo>
+                    <a:cubicBezTo>
+                      <a:pt x="425855" y="1753140"/>
+                      <a:pt x="361003" y="1902297"/>
+                      <a:pt x="285344" y="2049293"/>
+                    </a:cubicBezTo>
+                    <a:cubicBezTo>
+                      <a:pt x="209685" y="2196289"/>
+                      <a:pt x="0" y="2425430"/>
+                      <a:pt x="0" y="2425430"/>
+                    </a:cubicBezTo>
+                    <a:lnTo>
+                      <a:pt x="0" y="2425430"/>
+                    </a:lnTo>
+                  </a:path>
+                </a:pathLst>
+              </a:custGeom>
+              <a:noFill/>
+            </p:spPr>
+            <p:style>
+              <a:lnRef idx="2">
+                <a:schemeClr val="accent1">
+                  <a:shade val="15000"/>
+                </a:schemeClr>
+              </a:lnRef>
+              <a:fillRef idx="1">
+                <a:schemeClr val="accent1"/>
+              </a:fillRef>
+              <a:effectRef idx="0">
+                <a:schemeClr val="accent1"/>
+              </a:effectRef>
+              <a:fontRef idx="minor">
+                <a:schemeClr val="lt1"/>
+              </a:fontRef>
+            </p:style>
+            <p:txBody>
+              <a:bodyPr rtlCol="0" anchor="ctr"/>
+              <a:lstStyle/>
+              <a:p>
+                <a:pPr algn="ctr"/>
+                <a:endParaRPr lang="en-NZ"/>
+              </a:p>
+            </p:txBody>
+          </p:sp>
+          <p:sp>
+            <p:nvSpPr>
+              <p:cNvPr id="32" name="Oval 15">
+                <a:extLst>
+                  <a:ext uri="{FF2B5EF4-FFF2-40B4-BE49-F238E27FC236}">
+                    <a16:creationId xmlns:a16="http://schemas.microsoft.com/office/drawing/2014/main" id="{83E489AA-317F-AF71-A035-AB2F80606D29}"/>
+                  </a:ext>
+                </a:extLst>
+              </p:cNvPr>
+              <p:cNvSpPr/>
+              <p:nvPr/>
+            </p:nvSpPr>
+            <p:spPr>
+              <a:xfrm rot="1297676" flipH="1" flipV="1">
+                <a:off x="5798965" y="2887846"/>
+                <a:ext cx="336104" cy="74353"/>
+              </a:xfrm>
+              <a:custGeom>
+                <a:avLst/>
+                <a:gdLst>
+                  <a:gd name="csX0" fmla="*/ 0 w 525294"/>
+                  <a:gd name="csY0" fmla="*/ 94034 h 188068"/>
+                  <a:gd name="csX1" fmla="*/ 262647 w 525294"/>
+                  <a:gd name="csY1" fmla="*/ 0 h 188068"/>
+                  <a:gd name="csX2" fmla="*/ 525294 w 525294"/>
+                  <a:gd name="csY2" fmla="*/ 94034 h 188068"/>
+                  <a:gd name="csX3" fmla="*/ 262647 w 525294"/>
+                  <a:gd name="csY3" fmla="*/ 188068 h 188068"/>
+                  <a:gd name="csX4" fmla="*/ 0 w 525294"/>
+                  <a:gd name="csY4" fmla="*/ 94034 h 188068"/>
+                  <a:gd name="csX0" fmla="*/ 0 w 623481"/>
+                  <a:gd name="csY0" fmla="*/ 94831 h 189220"/>
+                  <a:gd name="csX1" fmla="*/ 262647 w 623481"/>
+                  <a:gd name="csY1" fmla="*/ 797 h 189220"/>
+                  <a:gd name="csX2" fmla="*/ 623481 w 623481"/>
+                  <a:gd name="csY2" fmla="*/ 65276 h 189220"/>
+                  <a:gd name="csX3" fmla="*/ 262647 w 623481"/>
+                  <a:gd name="csY3" fmla="*/ 188865 h 189220"/>
+                  <a:gd name="csX4" fmla="*/ 0 w 623481"/>
+                  <a:gd name="csY4" fmla="*/ 94831 h 189220"/>
+                </a:gdLst>
+                <a:ahLst/>
+                <a:cxnLst>
+                  <a:cxn ang="0">
+                    <a:pos x="csX0" y="csY0"/>
+                  </a:cxn>
+                  <a:cxn ang="0">
+                    <a:pos x="csX1" y="csY1"/>
+                  </a:cxn>
+                  <a:cxn ang="0">
+                    <a:pos x="csX2" y="csY2"/>
+                  </a:cxn>
+                  <a:cxn ang="0">
+                    <a:pos x="csX3" y="csY3"/>
+                  </a:cxn>
+                  <a:cxn ang="0">
+                    <a:pos x="csX4" y="csY4"/>
+                  </a:cxn>
+                </a:cxnLst>
+                <a:rect l="l" t="t" r="r" b="b"/>
+                <a:pathLst>
+                  <a:path w="623481" h="189220">
+                    <a:moveTo>
+                      <a:pt x="0" y="94831"/>
+                    </a:moveTo>
+                    <a:cubicBezTo>
+                      <a:pt x="0" y="42897"/>
+                      <a:pt x="158734" y="5723"/>
+                      <a:pt x="262647" y="797"/>
+                    </a:cubicBezTo>
+                    <a:cubicBezTo>
+                      <a:pt x="366560" y="-4129"/>
+                      <a:pt x="623481" y="13342"/>
+                      <a:pt x="623481" y="65276"/>
+                    </a:cubicBezTo>
+                    <a:cubicBezTo>
+                      <a:pt x="623481" y="117210"/>
+                      <a:pt x="366560" y="183939"/>
+                      <a:pt x="262647" y="188865"/>
+                    </a:cubicBezTo>
+                    <a:cubicBezTo>
+                      <a:pt x="158734" y="193791"/>
+                      <a:pt x="0" y="146765"/>
+                      <a:pt x="0" y="94831"/>
+                    </a:cubicBezTo>
+                    <a:close/>
+                  </a:path>
+                </a:pathLst>
+              </a:custGeom>
+              <a:solidFill>
+                <a:schemeClr val="accent6">
+                  <a:lumMod val="75000"/>
+                </a:schemeClr>
+              </a:solidFill>
+              <a:ln>
+                <a:solidFill>
+                  <a:schemeClr val="accent6">
+                    <a:lumMod val="75000"/>
+                  </a:schemeClr>
+                </a:solidFill>
+              </a:ln>
+            </p:spPr>
+            <p:style>
+              <a:lnRef idx="2">
+                <a:schemeClr val="accent6">
+                  <a:shade val="15000"/>
+                </a:schemeClr>
+              </a:lnRef>
+              <a:fillRef idx="1">
+                <a:schemeClr val="accent6"/>
+              </a:fillRef>
+              <a:effectRef idx="0">
+                <a:schemeClr val="accent6"/>
+              </a:effectRef>
+              <a:fontRef idx="minor">
+                <a:schemeClr val="lt1"/>
+              </a:fontRef>
+            </p:style>
+            <p:txBody>
+              <a:bodyPr rtlCol="0" anchor="ctr"/>
+              <a:lstStyle/>
+              <a:p>
+                <a:pPr algn="ctr"/>
+                <a:endParaRPr lang="en-NZ"/>
+              </a:p>
+            </p:txBody>
+          </p:sp>
+          <p:sp>
+            <p:nvSpPr>
+              <p:cNvPr id="34" name="Oval 15">
+                <a:extLst>
+                  <a:ext uri="{FF2B5EF4-FFF2-40B4-BE49-F238E27FC236}">
+                    <a16:creationId xmlns:a16="http://schemas.microsoft.com/office/drawing/2014/main" id="{80D1BDD5-71B9-1DBD-30D5-9316D6960DA5}"/>
+                  </a:ext>
+                </a:extLst>
+              </p:cNvPr>
+              <p:cNvSpPr/>
+              <p:nvPr/>
+            </p:nvSpPr>
+            <p:spPr>
+              <a:xfrm rot="2313172" flipH="1">
+                <a:off x="5931238" y="3687580"/>
+                <a:ext cx="368562" cy="86250"/>
+              </a:xfrm>
+              <a:custGeom>
+                <a:avLst/>
+                <a:gdLst>
+                  <a:gd name="csX0" fmla="*/ 0 w 525294"/>
+                  <a:gd name="csY0" fmla="*/ 94034 h 188068"/>
+                  <a:gd name="csX1" fmla="*/ 262647 w 525294"/>
+                  <a:gd name="csY1" fmla="*/ 0 h 188068"/>
+                  <a:gd name="csX2" fmla="*/ 525294 w 525294"/>
+                  <a:gd name="csY2" fmla="*/ 94034 h 188068"/>
+                  <a:gd name="csX3" fmla="*/ 262647 w 525294"/>
+                  <a:gd name="csY3" fmla="*/ 188068 h 188068"/>
+                  <a:gd name="csX4" fmla="*/ 0 w 525294"/>
+                  <a:gd name="csY4" fmla="*/ 94034 h 188068"/>
+                  <a:gd name="csX0" fmla="*/ 0 w 623481"/>
+                  <a:gd name="csY0" fmla="*/ 94831 h 189220"/>
+                  <a:gd name="csX1" fmla="*/ 262647 w 623481"/>
+                  <a:gd name="csY1" fmla="*/ 797 h 189220"/>
+                  <a:gd name="csX2" fmla="*/ 623481 w 623481"/>
+                  <a:gd name="csY2" fmla="*/ 65276 h 189220"/>
+                  <a:gd name="csX3" fmla="*/ 262647 w 623481"/>
+                  <a:gd name="csY3" fmla="*/ 188865 h 189220"/>
+                  <a:gd name="csX4" fmla="*/ 0 w 623481"/>
+                  <a:gd name="csY4" fmla="*/ 94831 h 189220"/>
+                </a:gdLst>
+                <a:ahLst/>
+                <a:cxnLst>
+                  <a:cxn ang="0">
+                    <a:pos x="csX0" y="csY0"/>
+                  </a:cxn>
+                  <a:cxn ang="0">
+                    <a:pos x="csX1" y="csY1"/>
+                  </a:cxn>
+                  <a:cxn ang="0">
+                    <a:pos x="csX2" y="csY2"/>
+                  </a:cxn>
+                  <a:cxn ang="0">
+                    <a:pos x="csX3" y="csY3"/>
+                  </a:cxn>
+                  <a:cxn ang="0">
+                    <a:pos x="csX4" y="csY4"/>
+                  </a:cxn>
+                </a:cxnLst>
+                <a:rect l="l" t="t" r="r" b="b"/>
+                <a:pathLst>
+                  <a:path w="623481" h="189220">
+                    <a:moveTo>
+                      <a:pt x="0" y="94831"/>
+                    </a:moveTo>
+                    <a:cubicBezTo>
+                      <a:pt x="0" y="42897"/>
+                      <a:pt x="158734" y="5723"/>
+                      <a:pt x="262647" y="797"/>
+                    </a:cubicBezTo>
+                    <a:cubicBezTo>
+                      <a:pt x="366560" y="-4129"/>
+                      <a:pt x="623481" y="13342"/>
+                      <a:pt x="623481" y="65276"/>
+                    </a:cubicBezTo>
+                    <a:cubicBezTo>
+                      <a:pt x="623481" y="117210"/>
+                      <a:pt x="366560" y="183939"/>
+                      <a:pt x="262647" y="188865"/>
+                    </a:cubicBezTo>
+                    <a:cubicBezTo>
+                      <a:pt x="158734" y="193791"/>
+                      <a:pt x="0" y="146765"/>
+                      <a:pt x="0" y="94831"/>
+                    </a:cubicBezTo>
+                    <a:close/>
+                  </a:path>
+                </a:pathLst>
+              </a:custGeom>
+              <a:solidFill>
+                <a:schemeClr val="accent6">
+                  <a:lumMod val="75000"/>
+                </a:schemeClr>
+              </a:solidFill>
+              <a:ln>
+                <a:solidFill>
+                  <a:schemeClr val="accent6">
+                    <a:lumMod val="75000"/>
+                  </a:schemeClr>
+                </a:solidFill>
+              </a:ln>
+            </p:spPr>
+            <p:style>
+              <a:lnRef idx="2">
+                <a:schemeClr val="accent6">
+                  <a:shade val="15000"/>
+                </a:schemeClr>
+              </a:lnRef>
+              <a:fillRef idx="1">
+                <a:schemeClr val="accent6"/>
+              </a:fillRef>
+              <a:effectRef idx="0">
+                <a:schemeClr val="accent6"/>
+              </a:effectRef>
+              <a:fontRef idx="minor">
+                <a:schemeClr val="lt1"/>
+              </a:fontRef>
+            </p:style>
+            <p:txBody>
+              <a:bodyPr rtlCol="0" anchor="ctr"/>
+              <a:lstStyle/>
+              <a:p>
+                <a:pPr algn="ctr"/>
+                <a:endParaRPr lang="en-NZ"/>
+              </a:p>
+            </p:txBody>
+          </p:sp>
+          <p:sp>
+            <p:nvSpPr>
+              <p:cNvPr id="36" name="Oval 15">
+                <a:extLst>
+                  <a:ext uri="{FF2B5EF4-FFF2-40B4-BE49-F238E27FC236}">
+                    <a16:creationId xmlns:a16="http://schemas.microsoft.com/office/drawing/2014/main" id="{8E3D0049-B1FC-EBA0-605F-F1FBFA3E1BEA}"/>
+                  </a:ext>
+                </a:extLst>
+              </p:cNvPr>
+              <p:cNvSpPr/>
+              <p:nvPr/>
+            </p:nvSpPr>
+            <p:spPr>
+              <a:xfrm rot="16599564">
+                <a:off x="5800619" y="2388447"/>
+                <a:ext cx="384004" cy="76570"/>
+              </a:xfrm>
+              <a:custGeom>
+                <a:avLst/>
+                <a:gdLst>
+                  <a:gd name="csX0" fmla="*/ 0 w 525294"/>
+                  <a:gd name="csY0" fmla="*/ 94034 h 188068"/>
+                  <a:gd name="csX1" fmla="*/ 262647 w 525294"/>
+                  <a:gd name="csY1" fmla="*/ 0 h 188068"/>
+                  <a:gd name="csX2" fmla="*/ 525294 w 525294"/>
+                  <a:gd name="csY2" fmla="*/ 94034 h 188068"/>
+                  <a:gd name="csX3" fmla="*/ 262647 w 525294"/>
+                  <a:gd name="csY3" fmla="*/ 188068 h 188068"/>
+                  <a:gd name="csX4" fmla="*/ 0 w 525294"/>
+                  <a:gd name="csY4" fmla="*/ 94034 h 188068"/>
+                  <a:gd name="csX0" fmla="*/ 0 w 623481"/>
+                  <a:gd name="csY0" fmla="*/ 94831 h 189220"/>
+                  <a:gd name="csX1" fmla="*/ 262647 w 623481"/>
+                  <a:gd name="csY1" fmla="*/ 797 h 189220"/>
+                  <a:gd name="csX2" fmla="*/ 623481 w 623481"/>
+                  <a:gd name="csY2" fmla="*/ 65276 h 189220"/>
+                  <a:gd name="csX3" fmla="*/ 262647 w 623481"/>
+                  <a:gd name="csY3" fmla="*/ 188865 h 189220"/>
+                  <a:gd name="csX4" fmla="*/ 0 w 623481"/>
+                  <a:gd name="csY4" fmla="*/ 94831 h 189220"/>
+                </a:gdLst>
+                <a:ahLst/>
+                <a:cxnLst>
+                  <a:cxn ang="0">
+                    <a:pos x="csX0" y="csY0"/>
+                  </a:cxn>
+                  <a:cxn ang="0">
+                    <a:pos x="csX1" y="csY1"/>
+                  </a:cxn>
+                  <a:cxn ang="0">
+                    <a:pos x="csX2" y="csY2"/>
+                  </a:cxn>
+                  <a:cxn ang="0">
+                    <a:pos x="csX3" y="csY3"/>
+                  </a:cxn>
+                  <a:cxn ang="0">
+                    <a:pos x="csX4" y="csY4"/>
+                  </a:cxn>
+                </a:cxnLst>
+                <a:rect l="l" t="t" r="r" b="b"/>
+                <a:pathLst>
+                  <a:path w="623481" h="189220">
+                    <a:moveTo>
+                      <a:pt x="0" y="94831"/>
+                    </a:moveTo>
+                    <a:cubicBezTo>
+                      <a:pt x="0" y="42897"/>
+                      <a:pt x="158734" y="5723"/>
+                      <a:pt x="262647" y="797"/>
+                    </a:cubicBezTo>
+                    <a:cubicBezTo>
+                      <a:pt x="366560" y="-4129"/>
+                      <a:pt x="623481" y="13342"/>
+                      <a:pt x="623481" y="65276"/>
+                    </a:cubicBezTo>
+                    <a:cubicBezTo>
+                      <a:pt x="623481" y="117210"/>
+                      <a:pt x="366560" y="183939"/>
+                      <a:pt x="262647" y="188865"/>
+                    </a:cubicBezTo>
+                    <a:cubicBezTo>
+                      <a:pt x="158734" y="193791"/>
+                      <a:pt x="0" y="146765"/>
+                      <a:pt x="0" y="94831"/>
+                    </a:cubicBezTo>
+                    <a:close/>
+                  </a:path>
+                </a:pathLst>
+              </a:custGeom>
+              <a:solidFill>
+                <a:schemeClr val="accent6">
+                  <a:lumMod val="75000"/>
+                </a:schemeClr>
+              </a:solidFill>
+              <a:ln>
+                <a:solidFill>
+                  <a:schemeClr val="accent6">
+                    <a:lumMod val="75000"/>
+                  </a:schemeClr>
+                </a:solidFill>
+              </a:ln>
+            </p:spPr>
+            <p:style>
+              <a:lnRef idx="2">
+                <a:schemeClr val="accent6">
+                  <a:shade val="15000"/>
+                </a:schemeClr>
+              </a:lnRef>
+              <a:fillRef idx="1">
+                <a:schemeClr val="accent6"/>
+              </a:fillRef>
+              <a:effectRef idx="0">
+                <a:schemeClr val="accent6"/>
+              </a:effectRef>
+              <a:fontRef idx="minor">
+                <a:schemeClr val="lt1"/>
+              </a:fontRef>
+            </p:style>
+            <p:txBody>
+              <a:bodyPr rtlCol="0" anchor="ctr"/>
+              <a:lstStyle/>
+              <a:p>
+                <a:pPr algn="ctr"/>
+                <a:endParaRPr lang="en-NZ"/>
+              </a:p>
+            </p:txBody>
+          </p:sp>
+          <p:sp>
+            <p:nvSpPr>
+              <p:cNvPr id="38" name="Oval 15">
+                <a:extLst>
+                  <a:ext uri="{FF2B5EF4-FFF2-40B4-BE49-F238E27FC236}">
+                    <a16:creationId xmlns:a16="http://schemas.microsoft.com/office/drawing/2014/main" id="{0307720A-F418-F4C6-1B9A-C52287454FF2}"/>
+                  </a:ext>
+                </a:extLst>
+              </p:cNvPr>
+              <p:cNvSpPr/>
+              <p:nvPr/>
+            </p:nvSpPr>
+            <p:spPr>
+              <a:xfrm rot="17720721">
+                <a:off x="6162584" y="3440791"/>
+                <a:ext cx="428121" cy="76467"/>
+              </a:xfrm>
+              <a:custGeom>
+                <a:avLst/>
+                <a:gdLst>
+                  <a:gd name="csX0" fmla="*/ 0 w 525294"/>
+                  <a:gd name="csY0" fmla="*/ 94034 h 188068"/>
+                  <a:gd name="csX1" fmla="*/ 262647 w 525294"/>
+                  <a:gd name="csY1" fmla="*/ 0 h 188068"/>
+                  <a:gd name="csX2" fmla="*/ 525294 w 525294"/>
+                  <a:gd name="csY2" fmla="*/ 94034 h 188068"/>
+                  <a:gd name="csX3" fmla="*/ 262647 w 525294"/>
+                  <a:gd name="csY3" fmla="*/ 188068 h 188068"/>
+                  <a:gd name="csX4" fmla="*/ 0 w 525294"/>
+                  <a:gd name="csY4" fmla="*/ 94034 h 188068"/>
+                  <a:gd name="csX0" fmla="*/ 0 w 623481"/>
+                  <a:gd name="csY0" fmla="*/ 94831 h 189220"/>
+                  <a:gd name="csX1" fmla="*/ 262647 w 623481"/>
+                  <a:gd name="csY1" fmla="*/ 797 h 189220"/>
+                  <a:gd name="csX2" fmla="*/ 623481 w 623481"/>
+                  <a:gd name="csY2" fmla="*/ 65276 h 189220"/>
+                  <a:gd name="csX3" fmla="*/ 262647 w 623481"/>
+                  <a:gd name="csY3" fmla="*/ 188865 h 189220"/>
+                  <a:gd name="csX4" fmla="*/ 0 w 623481"/>
+                  <a:gd name="csY4" fmla="*/ 94831 h 189220"/>
+                </a:gdLst>
+                <a:ahLst/>
+                <a:cxnLst>
+                  <a:cxn ang="0">
+                    <a:pos x="csX0" y="csY0"/>
+                  </a:cxn>
+                  <a:cxn ang="0">
+                    <a:pos x="csX1" y="csY1"/>
+                  </a:cxn>
+                  <a:cxn ang="0">
+                    <a:pos x="csX2" y="csY2"/>
+                  </a:cxn>
+                  <a:cxn ang="0">
+                    <a:pos x="csX3" y="csY3"/>
+                  </a:cxn>
+                  <a:cxn ang="0">
+                    <a:pos x="csX4" y="csY4"/>
+                  </a:cxn>
+                </a:cxnLst>
+                <a:rect l="l" t="t" r="r" b="b"/>
+                <a:pathLst>
+                  <a:path w="623481" h="189220">
+                    <a:moveTo>
+                      <a:pt x="0" y="94831"/>
+                    </a:moveTo>
+                    <a:cubicBezTo>
+                      <a:pt x="0" y="42897"/>
+                      <a:pt x="158734" y="5723"/>
+                      <a:pt x="262647" y="797"/>
+                    </a:cubicBezTo>
+                    <a:cubicBezTo>
+                      <a:pt x="366560" y="-4129"/>
+                      <a:pt x="623481" y="13342"/>
+                      <a:pt x="623481" y="65276"/>
+                    </a:cubicBezTo>
+                    <a:cubicBezTo>
+                      <a:pt x="623481" y="117210"/>
+                      <a:pt x="366560" y="183939"/>
+                      <a:pt x="262647" y="188865"/>
+                    </a:cubicBezTo>
+                    <a:cubicBezTo>
+                      <a:pt x="158734" y="193791"/>
+                      <a:pt x="0" y="146765"/>
+                      <a:pt x="0" y="94831"/>
+                    </a:cubicBezTo>
+                    <a:close/>
+                  </a:path>
+                </a:pathLst>
+              </a:custGeom>
+              <a:solidFill>
+                <a:schemeClr val="accent6">
+                  <a:lumMod val="75000"/>
+                </a:schemeClr>
+              </a:solidFill>
+              <a:ln>
+                <a:solidFill>
+                  <a:schemeClr val="accent6">
+                    <a:lumMod val="75000"/>
+                  </a:schemeClr>
+                </a:solidFill>
+              </a:ln>
+            </p:spPr>
+            <p:style>
+              <a:lnRef idx="2">
+                <a:schemeClr val="accent6">
+                  <a:shade val="15000"/>
+                </a:schemeClr>
+              </a:lnRef>
+              <a:fillRef idx="1">
+                <a:schemeClr val="accent6"/>
+              </a:fillRef>
+              <a:effectRef idx="0">
+                <a:schemeClr val="accent6"/>
+              </a:effectRef>
+              <a:fontRef idx="minor">
+                <a:schemeClr val="lt1"/>
+              </a:fontRef>
+            </p:style>
+            <p:txBody>
+              <a:bodyPr rtlCol="0" anchor="ctr"/>
+              <a:lstStyle/>
+              <a:p>
+                <a:pPr algn="ctr"/>
+                <a:endParaRPr lang="en-NZ"/>
+              </a:p>
+            </p:txBody>
+          </p:sp>
+          <p:sp>
+            <p:nvSpPr>
+              <p:cNvPr id="40" name="Oval 15">
+                <a:extLst>
+                  <a:ext uri="{FF2B5EF4-FFF2-40B4-BE49-F238E27FC236}">
+                    <a16:creationId xmlns:a16="http://schemas.microsoft.com/office/drawing/2014/main" id="{0CD7B202-5966-24EC-B6C3-2001879D4628}"/>
+                  </a:ext>
+                </a:extLst>
+              </p:cNvPr>
+              <p:cNvSpPr/>
+              <p:nvPr/>
+            </p:nvSpPr>
+            <p:spPr>
+              <a:xfrm rot="17826229">
+                <a:off x="6168485" y="3764374"/>
+                <a:ext cx="428121" cy="90431"/>
+              </a:xfrm>
+              <a:custGeom>
+                <a:avLst/>
+                <a:gdLst>
+                  <a:gd name="csX0" fmla="*/ 0 w 525294"/>
+                  <a:gd name="csY0" fmla="*/ 94034 h 188068"/>
+                  <a:gd name="csX1" fmla="*/ 262647 w 525294"/>
+                  <a:gd name="csY1" fmla="*/ 0 h 188068"/>
+                  <a:gd name="csX2" fmla="*/ 525294 w 525294"/>
+                  <a:gd name="csY2" fmla="*/ 94034 h 188068"/>
+                  <a:gd name="csX3" fmla="*/ 262647 w 525294"/>
+                  <a:gd name="csY3" fmla="*/ 188068 h 188068"/>
+                  <a:gd name="csX4" fmla="*/ 0 w 525294"/>
+                  <a:gd name="csY4" fmla="*/ 94034 h 188068"/>
+                  <a:gd name="csX0" fmla="*/ 0 w 623481"/>
+                  <a:gd name="csY0" fmla="*/ 94831 h 189220"/>
+                  <a:gd name="csX1" fmla="*/ 262647 w 623481"/>
+                  <a:gd name="csY1" fmla="*/ 797 h 189220"/>
+                  <a:gd name="csX2" fmla="*/ 623481 w 623481"/>
+                  <a:gd name="csY2" fmla="*/ 65276 h 189220"/>
+                  <a:gd name="csX3" fmla="*/ 262647 w 623481"/>
+                  <a:gd name="csY3" fmla="*/ 188865 h 189220"/>
+                  <a:gd name="csX4" fmla="*/ 0 w 623481"/>
+                  <a:gd name="csY4" fmla="*/ 94831 h 189220"/>
+                </a:gdLst>
+                <a:ahLst/>
+                <a:cxnLst>
+                  <a:cxn ang="0">
+                    <a:pos x="csX0" y="csY0"/>
+                  </a:cxn>
+                  <a:cxn ang="0">
+                    <a:pos x="csX1" y="csY1"/>
+                  </a:cxn>
+                  <a:cxn ang="0">
+                    <a:pos x="csX2" y="csY2"/>
+                  </a:cxn>
+                  <a:cxn ang="0">
+                    <a:pos x="csX3" y="csY3"/>
+                  </a:cxn>
+                  <a:cxn ang="0">
+                    <a:pos x="csX4" y="csY4"/>
+                  </a:cxn>
+                </a:cxnLst>
+                <a:rect l="l" t="t" r="r" b="b"/>
+                <a:pathLst>
+                  <a:path w="623481" h="189220">
+                    <a:moveTo>
+                      <a:pt x="0" y="94831"/>
+                    </a:moveTo>
+                    <a:cubicBezTo>
+                      <a:pt x="0" y="42897"/>
+                      <a:pt x="158734" y="5723"/>
+                      <a:pt x="262647" y="797"/>
+                    </a:cubicBezTo>
+                    <a:cubicBezTo>
+                      <a:pt x="366560" y="-4129"/>
+                      <a:pt x="623481" y="13342"/>
+                      <a:pt x="623481" y="65276"/>
+                    </a:cubicBezTo>
+                    <a:cubicBezTo>
+                      <a:pt x="623481" y="117210"/>
+                      <a:pt x="366560" y="183939"/>
+                      <a:pt x="262647" y="188865"/>
+                    </a:cubicBezTo>
+                    <a:cubicBezTo>
+                      <a:pt x="158734" y="193791"/>
+                      <a:pt x="0" y="146765"/>
+                      <a:pt x="0" y="94831"/>
+                    </a:cubicBezTo>
+                    <a:close/>
+                  </a:path>
+                </a:pathLst>
+              </a:custGeom>
+              <a:solidFill>
+                <a:schemeClr val="accent6">
+                  <a:lumMod val="75000"/>
+                </a:schemeClr>
+              </a:solidFill>
+              <a:ln>
+                <a:solidFill>
+                  <a:schemeClr val="accent6">
+                    <a:lumMod val="75000"/>
+                  </a:schemeClr>
+                </a:solidFill>
+              </a:ln>
+            </p:spPr>
+            <p:style>
+              <a:lnRef idx="2">
+                <a:schemeClr val="accent6">
+                  <a:shade val="15000"/>
+                </a:schemeClr>
+              </a:lnRef>
+              <a:fillRef idx="1">
+                <a:schemeClr val="accent6"/>
+              </a:fillRef>
+              <a:effectRef idx="0">
+                <a:schemeClr val="accent6"/>
+              </a:effectRef>
+              <a:fontRef idx="minor">
+                <a:schemeClr val="lt1"/>
+              </a:fontRef>
+            </p:style>
+            <p:txBody>
+              <a:bodyPr rtlCol="0" anchor="ctr"/>
+              <a:lstStyle/>
+              <a:p>
+                <a:pPr algn="ctr"/>
+                <a:endParaRPr lang="en-NZ"/>
+              </a:p>
+            </p:txBody>
+          </p:sp>
+        </p:grpSp>
+        <p:grpSp>
+          <p:nvGrpSpPr>
+            <p:cNvPr id="42" name="Group 41">
+              <a:extLst>
+                <a:ext uri="{FF2B5EF4-FFF2-40B4-BE49-F238E27FC236}">
+                  <a16:creationId xmlns:a16="http://schemas.microsoft.com/office/drawing/2014/main" id="{34924CB9-E56C-60EE-1D03-56FAD016403D}"/>
+                </a:ext>
+              </a:extLst>
+            </p:cNvPr>
+            <p:cNvGrpSpPr/>
+            <p:nvPr/>
+          </p:nvGrpSpPr>
+          <p:grpSpPr>
+            <a:xfrm flipH="1">
+              <a:off x="2997047" y="2187673"/>
+              <a:ext cx="750300" cy="2737251"/>
+              <a:chOff x="5677461" y="2176091"/>
+              <a:chExt cx="750300" cy="2737251"/>
+            </a:xfrm>
+          </p:grpSpPr>
+          <p:sp>
+            <p:nvSpPr>
+              <p:cNvPr id="43" name="Oval 15">
+                <a:extLst>
+                  <a:ext uri="{FF2B5EF4-FFF2-40B4-BE49-F238E27FC236}">
+                    <a16:creationId xmlns:a16="http://schemas.microsoft.com/office/drawing/2014/main" id="{6FAFF837-16C2-0713-E4AC-8F5046A999B9}"/>
+                  </a:ext>
+                </a:extLst>
+              </p:cNvPr>
+              <p:cNvSpPr/>
+              <p:nvPr/>
+            </p:nvSpPr>
+            <p:spPr>
+              <a:xfrm rot="1439914" flipH="1">
+                <a:off x="5873621" y="3072463"/>
+                <a:ext cx="358584" cy="83907"/>
+              </a:xfrm>
+              <a:custGeom>
+                <a:avLst/>
+                <a:gdLst>
+                  <a:gd name="csX0" fmla="*/ 0 w 525294"/>
+                  <a:gd name="csY0" fmla="*/ 94034 h 188068"/>
+                  <a:gd name="csX1" fmla="*/ 262647 w 525294"/>
+                  <a:gd name="csY1" fmla="*/ 0 h 188068"/>
+                  <a:gd name="csX2" fmla="*/ 525294 w 525294"/>
+                  <a:gd name="csY2" fmla="*/ 94034 h 188068"/>
+                  <a:gd name="csX3" fmla="*/ 262647 w 525294"/>
+                  <a:gd name="csY3" fmla="*/ 188068 h 188068"/>
+                  <a:gd name="csX4" fmla="*/ 0 w 525294"/>
+                  <a:gd name="csY4" fmla="*/ 94034 h 188068"/>
+                  <a:gd name="csX0" fmla="*/ 0 w 623481"/>
+                  <a:gd name="csY0" fmla="*/ 94831 h 189220"/>
+                  <a:gd name="csX1" fmla="*/ 262647 w 623481"/>
+                  <a:gd name="csY1" fmla="*/ 797 h 189220"/>
+                  <a:gd name="csX2" fmla="*/ 623481 w 623481"/>
+                  <a:gd name="csY2" fmla="*/ 65276 h 189220"/>
+                  <a:gd name="csX3" fmla="*/ 262647 w 623481"/>
+                  <a:gd name="csY3" fmla="*/ 188865 h 189220"/>
+                  <a:gd name="csX4" fmla="*/ 0 w 623481"/>
+                  <a:gd name="csY4" fmla="*/ 94831 h 189220"/>
+                </a:gdLst>
+                <a:ahLst/>
+                <a:cxnLst>
+                  <a:cxn ang="0">
+                    <a:pos x="csX0" y="csY0"/>
+                  </a:cxn>
+                  <a:cxn ang="0">
+                    <a:pos x="csX1" y="csY1"/>
+                  </a:cxn>
+                  <a:cxn ang="0">
+                    <a:pos x="csX2" y="csY2"/>
+                  </a:cxn>
+                  <a:cxn ang="0">
+                    <a:pos x="csX3" y="csY3"/>
+                  </a:cxn>
+                  <a:cxn ang="0">
+                    <a:pos x="csX4" y="csY4"/>
+                  </a:cxn>
+                </a:cxnLst>
+                <a:rect l="l" t="t" r="r" b="b"/>
+                <a:pathLst>
+                  <a:path w="623481" h="189220">
+                    <a:moveTo>
+                      <a:pt x="0" y="94831"/>
+                    </a:moveTo>
+                    <a:cubicBezTo>
+                      <a:pt x="0" y="42897"/>
+                      <a:pt x="158734" y="5723"/>
+                      <a:pt x="262647" y="797"/>
+                    </a:cubicBezTo>
+                    <a:cubicBezTo>
+                      <a:pt x="366560" y="-4129"/>
+                      <a:pt x="623481" y="13342"/>
+                      <a:pt x="623481" y="65276"/>
+                    </a:cubicBezTo>
+                    <a:cubicBezTo>
+                      <a:pt x="623481" y="117210"/>
+                      <a:pt x="366560" y="183939"/>
+                      <a:pt x="262647" y="188865"/>
+                    </a:cubicBezTo>
+                    <a:cubicBezTo>
+                      <a:pt x="158734" y="193791"/>
+                      <a:pt x="0" y="146765"/>
+                      <a:pt x="0" y="94831"/>
+                    </a:cubicBezTo>
+                    <a:close/>
+                  </a:path>
+                </a:pathLst>
+              </a:custGeom>
+              <a:solidFill>
+                <a:schemeClr val="accent6">
+                  <a:lumMod val="75000"/>
+                </a:schemeClr>
+              </a:solidFill>
+              <a:ln>
+                <a:solidFill>
+                  <a:schemeClr val="accent6">
+                    <a:lumMod val="75000"/>
+                  </a:schemeClr>
+                </a:solidFill>
+              </a:ln>
+            </p:spPr>
+            <p:style>
+              <a:lnRef idx="2">
+                <a:schemeClr val="accent6">
+                  <a:shade val="15000"/>
+                </a:schemeClr>
+              </a:lnRef>
+              <a:fillRef idx="1">
+                <a:schemeClr val="accent6"/>
+              </a:fillRef>
+              <a:effectRef idx="0">
+                <a:schemeClr val="accent6"/>
+              </a:effectRef>
+              <a:fontRef idx="minor">
+                <a:schemeClr val="lt1"/>
+              </a:fontRef>
+            </p:style>
+            <p:txBody>
+              <a:bodyPr rtlCol="0" anchor="ctr"/>
+              <a:lstStyle/>
+              <a:p>
+                <a:pPr algn="ctr"/>
+                <a:endParaRPr lang="en-NZ"/>
+              </a:p>
+            </p:txBody>
+          </p:sp>
+          <p:sp>
+            <p:nvSpPr>
+              <p:cNvPr id="44" name="Oval 15">
+                <a:extLst>
+                  <a:ext uri="{FF2B5EF4-FFF2-40B4-BE49-F238E27FC236}">
+                    <a16:creationId xmlns:a16="http://schemas.microsoft.com/office/drawing/2014/main" id="{D4EF5C35-6F13-CE1A-5BA5-E5919D67F4AA}"/>
+                  </a:ext>
+                </a:extLst>
+              </p:cNvPr>
+              <p:cNvSpPr/>
+              <p:nvPr/>
+            </p:nvSpPr>
+            <p:spPr>
+              <a:xfrm rot="1297676" flipH="1">
+                <a:off x="5677461" y="2648054"/>
+                <a:ext cx="336104" cy="93295"/>
+              </a:xfrm>
+              <a:custGeom>
+                <a:avLst/>
+                <a:gdLst>
+                  <a:gd name="csX0" fmla="*/ 0 w 525294"/>
+                  <a:gd name="csY0" fmla="*/ 94034 h 188068"/>
+                  <a:gd name="csX1" fmla="*/ 262647 w 525294"/>
+                  <a:gd name="csY1" fmla="*/ 0 h 188068"/>
+                  <a:gd name="csX2" fmla="*/ 525294 w 525294"/>
+                  <a:gd name="csY2" fmla="*/ 94034 h 188068"/>
+                  <a:gd name="csX3" fmla="*/ 262647 w 525294"/>
+                  <a:gd name="csY3" fmla="*/ 188068 h 188068"/>
+                  <a:gd name="csX4" fmla="*/ 0 w 525294"/>
+                  <a:gd name="csY4" fmla="*/ 94034 h 188068"/>
+                  <a:gd name="csX0" fmla="*/ 0 w 623481"/>
+                  <a:gd name="csY0" fmla="*/ 94831 h 189220"/>
+                  <a:gd name="csX1" fmla="*/ 262647 w 623481"/>
+                  <a:gd name="csY1" fmla="*/ 797 h 189220"/>
+                  <a:gd name="csX2" fmla="*/ 623481 w 623481"/>
+                  <a:gd name="csY2" fmla="*/ 65276 h 189220"/>
+                  <a:gd name="csX3" fmla="*/ 262647 w 623481"/>
+                  <a:gd name="csY3" fmla="*/ 188865 h 189220"/>
+                  <a:gd name="csX4" fmla="*/ 0 w 623481"/>
+                  <a:gd name="csY4" fmla="*/ 94831 h 189220"/>
+                </a:gdLst>
+                <a:ahLst/>
+                <a:cxnLst>
+                  <a:cxn ang="0">
+                    <a:pos x="csX0" y="csY0"/>
+                  </a:cxn>
+                  <a:cxn ang="0">
+                    <a:pos x="csX1" y="csY1"/>
+                  </a:cxn>
+                  <a:cxn ang="0">
+                    <a:pos x="csX2" y="csY2"/>
+                  </a:cxn>
+                  <a:cxn ang="0">
+                    <a:pos x="csX3" y="csY3"/>
+                  </a:cxn>
+                  <a:cxn ang="0">
+                    <a:pos x="csX4" y="csY4"/>
+                  </a:cxn>
+                </a:cxnLst>
+                <a:rect l="l" t="t" r="r" b="b"/>
+                <a:pathLst>
+                  <a:path w="623481" h="189220">
+                    <a:moveTo>
+                      <a:pt x="0" y="94831"/>
+                    </a:moveTo>
+                    <a:cubicBezTo>
+                      <a:pt x="0" y="42897"/>
+                      <a:pt x="158734" y="5723"/>
+                      <a:pt x="262647" y="797"/>
+                    </a:cubicBezTo>
+                    <a:cubicBezTo>
+                      <a:pt x="366560" y="-4129"/>
+                      <a:pt x="623481" y="13342"/>
+                      <a:pt x="623481" y="65276"/>
+                    </a:cubicBezTo>
+                    <a:cubicBezTo>
+                      <a:pt x="623481" y="117210"/>
+                      <a:pt x="366560" y="183939"/>
+                      <a:pt x="262647" y="188865"/>
+                    </a:cubicBezTo>
+                    <a:cubicBezTo>
+                      <a:pt x="158734" y="193791"/>
+                      <a:pt x="0" y="146765"/>
+                      <a:pt x="0" y="94831"/>
+                    </a:cubicBezTo>
+                    <a:close/>
+                  </a:path>
+                </a:pathLst>
+              </a:custGeom>
+              <a:solidFill>
+                <a:schemeClr val="accent6">
+                  <a:lumMod val="75000"/>
+                </a:schemeClr>
+              </a:solidFill>
+              <a:ln>
+                <a:solidFill>
+                  <a:schemeClr val="accent6">
+                    <a:lumMod val="75000"/>
+                  </a:schemeClr>
+                </a:solidFill>
+              </a:ln>
+            </p:spPr>
+            <p:style>
+              <a:lnRef idx="2">
+                <a:schemeClr val="accent6">
+                  <a:shade val="15000"/>
+                </a:schemeClr>
+              </a:lnRef>
+              <a:fillRef idx="1">
+                <a:schemeClr val="accent6"/>
+              </a:fillRef>
+              <a:effectRef idx="0">
+                <a:schemeClr val="accent6"/>
+              </a:effectRef>
+              <a:fontRef idx="minor">
+                <a:schemeClr val="lt1"/>
+              </a:fontRef>
+            </p:style>
+            <p:txBody>
+              <a:bodyPr rtlCol="0" anchor="ctr"/>
+              <a:lstStyle/>
+              <a:p>
+                <a:pPr algn="ctr"/>
+                <a:endParaRPr lang="en-NZ"/>
+              </a:p>
+            </p:txBody>
+          </p:sp>
+          <p:sp>
+            <p:nvSpPr>
+              <p:cNvPr id="45" name="Oval 15">
+                <a:extLst>
+                  <a:ext uri="{FF2B5EF4-FFF2-40B4-BE49-F238E27FC236}">
+                    <a16:creationId xmlns:a16="http://schemas.microsoft.com/office/drawing/2014/main" id="{0D57873D-3B98-B4B8-D745-1DCE537C6F86}"/>
+                  </a:ext>
+                </a:extLst>
+              </p:cNvPr>
+              <p:cNvSpPr/>
+              <p:nvPr/>
+            </p:nvSpPr>
+            <p:spPr>
+              <a:xfrm rot="16971223">
+                <a:off x="6035007" y="2816575"/>
+                <a:ext cx="428121" cy="76467"/>
+              </a:xfrm>
+              <a:custGeom>
+                <a:avLst/>
+                <a:gdLst>
+                  <a:gd name="csX0" fmla="*/ 0 w 525294"/>
+                  <a:gd name="csY0" fmla="*/ 94034 h 188068"/>
+                  <a:gd name="csX1" fmla="*/ 262647 w 525294"/>
+                  <a:gd name="csY1" fmla="*/ 0 h 188068"/>
+                  <a:gd name="csX2" fmla="*/ 525294 w 525294"/>
+                  <a:gd name="csY2" fmla="*/ 94034 h 188068"/>
+                  <a:gd name="csX3" fmla="*/ 262647 w 525294"/>
+                  <a:gd name="csY3" fmla="*/ 188068 h 188068"/>
+                  <a:gd name="csX4" fmla="*/ 0 w 525294"/>
+                  <a:gd name="csY4" fmla="*/ 94034 h 188068"/>
+                  <a:gd name="csX0" fmla="*/ 0 w 623481"/>
+                  <a:gd name="csY0" fmla="*/ 94831 h 189220"/>
+                  <a:gd name="csX1" fmla="*/ 262647 w 623481"/>
+                  <a:gd name="csY1" fmla="*/ 797 h 189220"/>
+                  <a:gd name="csX2" fmla="*/ 623481 w 623481"/>
+                  <a:gd name="csY2" fmla="*/ 65276 h 189220"/>
+                  <a:gd name="csX3" fmla="*/ 262647 w 623481"/>
+                  <a:gd name="csY3" fmla="*/ 188865 h 189220"/>
+                  <a:gd name="csX4" fmla="*/ 0 w 623481"/>
+                  <a:gd name="csY4" fmla="*/ 94831 h 189220"/>
+                </a:gdLst>
+                <a:ahLst/>
+                <a:cxnLst>
+                  <a:cxn ang="0">
+                    <a:pos x="csX0" y="csY0"/>
+                  </a:cxn>
+                  <a:cxn ang="0">
+                    <a:pos x="csX1" y="csY1"/>
+                  </a:cxn>
+                  <a:cxn ang="0">
+                    <a:pos x="csX2" y="csY2"/>
+                  </a:cxn>
+                  <a:cxn ang="0">
+                    <a:pos x="csX3" y="csY3"/>
+                  </a:cxn>
+                  <a:cxn ang="0">
+                    <a:pos x="csX4" y="csY4"/>
+                  </a:cxn>
+                </a:cxnLst>
+                <a:rect l="l" t="t" r="r" b="b"/>
+                <a:pathLst>
+                  <a:path w="623481" h="189220">
+                    <a:moveTo>
+                      <a:pt x="0" y="94831"/>
+                    </a:moveTo>
+                    <a:cubicBezTo>
+                      <a:pt x="0" y="42897"/>
+                      <a:pt x="158734" y="5723"/>
+                      <a:pt x="262647" y="797"/>
+                    </a:cubicBezTo>
+                    <a:cubicBezTo>
+                      <a:pt x="366560" y="-4129"/>
+                      <a:pt x="623481" y="13342"/>
+                      <a:pt x="623481" y="65276"/>
+                    </a:cubicBezTo>
+                    <a:cubicBezTo>
+                      <a:pt x="623481" y="117210"/>
+                      <a:pt x="366560" y="183939"/>
+                      <a:pt x="262647" y="188865"/>
+                    </a:cubicBezTo>
+                    <a:cubicBezTo>
+                      <a:pt x="158734" y="193791"/>
+                      <a:pt x="0" y="146765"/>
+                      <a:pt x="0" y="94831"/>
+                    </a:cubicBezTo>
+                    <a:close/>
+                  </a:path>
+                </a:pathLst>
+              </a:custGeom>
+              <a:solidFill>
+                <a:schemeClr val="accent6">
+                  <a:lumMod val="75000"/>
+                </a:schemeClr>
+              </a:solidFill>
+              <a:ln>
+                <a:solidFill>
+                  <a:schemeClr val="accent6">
+                    <a:lumMod val="75000"/>
+                  </a:schemeClr>
+                </a:solidFill>
+              </a:ln>
+            </p:spPr>
+            <p:style>
+              <a:lnRef idx="2">
+                <a:schemeClr val="accent6">
+                  <a:shade val="15000"/>
+                </a:schemeClr>
+              </a:lnRef>
+              <a:fillRef idx="1">
+                <a:schemeClr val="accent6"/>
+              </a:fillRef>
+              <a:effectRef idx="0">
+                <a:schemeClr val="accent6"/>
+              </a:effectRef>
+              <a:fontRef idx="minor">
+                <a:schemeClr val="lt1"/>
+              </a:fontRef>
+            </p:style>
+            <p:txBody>
+              <a:bodyPr rtlCol="0" anchor="ctr"/>
+              <a:lstStyle/>
+              <a:p>
+                <a:pPr algn="ctr"/>
+                <a:endParaRPr lang="en-NZ"/>
+              </a:p>
+            </p:txBody>
+          </p:sp>
+          <p:sp>
+            <p:nvSpPr>
+              <p:cNvPr id="46" name="Oval 15">
+                <a:extLst>
+                  <a:ext uri="{FF2B5EF4-FFF2-40B4-BE49-F238E27FC236}">
+                    <a16:creationId xmlns:a16="http://schemas.microsoft.com/office/drawing/2014/main" id="{D21E51AF-5437-6156-DBFD-1104AA7F5B95}"/>
+                  </a:ext>
+                </a:extLst>
+              </p:cNvPr>
+              <p:cNvSpPr/>
+              <p:nvPr/>
+            </p:nvSpPr>
+            <p:spPr>
+              <a:xfrm rot="16672422">
+                <a:off x="5925138" y="2645257"/>
+                <a:ext cx="384004" cy="76570"/>
+              </a:xfrm>
+              <a:custGeom>
+                <a:avLst/>
+                <a:gdLst>
+                  <a:gd name="csX0" fmla="*/ 0 w 525294"/>
+                  <a:gd name="csY0" fmla="*/ 94034 h 188068"/>
+                  <a:gd name="csX1" fmla="*/ 262647 w 525294"/>
+                  <a:gd name="csY1" fmla="*/ 0 h 188068"/>
+                  <a:gd name="csX2" fmla="*/ 525294 w 525294"/>
+                  <a:gd name="csY2" fmla="*/ 94034 h 188068"/>
+                  <a:gd name="csX3" fmla="*/ 262647 w 525294"/>
+                  <a:gd name="csY3" fmla="*/ 188068 h 188068"/>
+                  <a:gd name="csX4" fmla="*/ 0 w 525294"/>
+                  <a:gd name="csY4" fmla="*/ 94034 h 188068"/>
+                  <a:gd name="csX0" fmla="*/ 0 w 623481"/>
+                  <a:gd name="csY0" fmla="*/ 94831 h 189220"/>
+                  <a:gd name="csX1" fmla="*/ 262647 w 623481"/>
+                  <a:gd name="csY1" fmla="*/ 797 h 189220"/>
+                  <a:gd name="csX2" fmla="*/ 623481 w 623481"/>
+                  <a:gd name="csY2" fmla="*/ 65276 h 189220"/>
+                  <a:gd name="csX3" fmla="*/ 262647 w 623481"/>
+                  <a:gd name="csY3" fmla="*/ 188865 h 189220"/>
+                  <a:gd name="csX4" fmla="*/ 0 w 623481"/>
+                  <a:gd name="csY4" fmla="*/ 94831 h 189220"/>
+                </a:gdLst>
+                <a:ahLst/>
+                <a:cxnLst>
+                  <a:cxn ang="0">
+                    <a:pos x="csX0" y="csY0"/>
+                  </a:cxn>
+                  <a:cxn ang="0">
+                    <a:pos x="csX1" y="csY1"/>
+                  </a:cxn>
+                  <a:cxn ang="0">
+                    <a:pos x="csX2" y="csY2"/>
+                  </a:cxn>
+                  <a:cxn ang="0">
+                    <a:pos x="csX3" y="csY3"/>
+                  </a:cxn>
+                  <a:cxn ang="0">
+                    <a:pos x="csX4" y="csY4"/>
+                  </a:cxn>
+                </a:cxnLst>
+                <a:rect l="l" t="t" r="r" b="b"/>
+                <a:pathLst>
+                  <a:path w="623481" h="189220">
+                    <a:moveTo>
+                      <a:pt x="0" y="94831"/>
+                    </a:moveTo>
+                    <a:cubicBezTo>
+                      <a:pt x="0" y="42897"/>
+                      <a:pt x="158734" y="5723"/>
+                      <a:pt x="262647" y="797"/>
+                    </a:cubicBezTo>
+                    <a:cubicBezTo>
+                      <a:pt x="366560" y="-4129"/>
+                      <a:pt x="623481" y="13342"/>
+                      <a:pt x="623481" y="65276"/>
+                    </a:cubicBezTo>
+                    <a:cubicBezTo>
+                      <a:pt x="623481" y="117210"/>
+                      <a:pt x="366560" y="183939"/>
+                      <a:pt x="262647" y="188865"/>
+                    </a:cubicBezTo>
+                    <a:cubicBezTo>
+                      <a:pt x="158734" y="193791"/>
+                      <a:pt x="0" y="146765"/>
+                      <a:pt x="0" y="94831"/>
+                    </a:cubicBezTo>
+                    <a:close/>
+                  </a:path>
+                </a:pathLst>
+              </a:custGeom>
+              <a:solidFill>
+                <a:schemeClr val="accent6">
+                  <a:lumMod val="75000"/>
+                </a:schemeClr>
+              </a:solidFill>
+              <a:ln>
+                <a:solidFill>
+                  <a:schemeClr val="accent6">
+                    <a:lumMod val="75000"/>
+                  </a:schemeClr>
+                </a:solidFill>
+              </a:ln>
+            </p:spPr>
+            <p:style>
+              <a:lnRef idx="2">
+                <a:schemeClr val="accent6">
+                  <a:shade val="15000"/>
+                </a:schemeClr>
+              </a:lnRef>
+              <a:fillRef idx="1">
+                <a:schemeClr val="accent6"/>
+              </a:fillRef>
+              <a:effectRef idx="0">
+                <a:schemeClr val="accent6"/>
+              </a:effectRef>
+              <a:fontRef idx="minor">
+                <a:schemeClr val="lt1"/>
+              </a:fontRef>
+            </p:style>
+            <p:txBody>
+              <a:bodyPr rtlCol="0" anchor="ctr"/>
+              <a:lstStyle/>
+              <a:p>
+                <a:pPr algn="ctr"/>
+                <a:endParaRPr lang="en-NZ"/>
+              </a:p>
+            </p:txBody>
+          </p:sp>
+          <p:sp>
+            <p:nvSpPr>
+              <p:cNvPr id="47" name="Oval 15">
+                <a:extLst>
+                  <a:ext uri="{FF2B5EF4-FFF2-40B4-BE49-F238E27FC236}">
+                    <a16:creationId xmlns:a16="http://schemas.microsoft.com/office/drawing/2014/main" id="{6E3A296F-05C6-8F46-539F-94C0F890FDCF}"/>
+                  </a:ext>
+                </a:extLst>
+              </p:cNvPr>
+              <p:cNvSpPr/>
+              <p:nvPr/>
+            </p:nvSpPr>
+            <p:spPr>
+              <a:xfrm rot="14162025">
+                <a:off x="5581911" y="2324390"/>
+                <a:ext cx="367317" cy="70720"/>
+              </a:xfrm>
+              <a:custGeom>
+                <a:avLst/>
+                <a:gdLst>
+                  <a:gd name="csX0" fmla="*/ 0 w 525294"/>
+                  <a:gd name="csY0" fmla="*/ 94034 h 188068"/>
+                  <a:gd name="csX1" fmla="*/ 262647 w 525294"/>
+                  <a:gd name="csY1" fmla="*/ 0 h 188068"/>
+                  <a:gd name="csX2" fmla="*/ 525294 w 525294"/>
+                  <a:gd name="csY2" fmla="*/ 94034 h 188068"/>
+                  <a:gd name="csX3" fmla="*/ 262647 w 525294"/>
+                  <a:gd name="csY3" fmla="*/ 188068 h 188068"/>
+                  <a:gd name="csX4" fmla="*/ 0 w 525294"/>
+                  <a:gd name="csY4" fmla="*/ 94034 h 188068"/>
+                  <a:gd name="csX0" fmla="*/ 0 w 623481"/>
+                  <a:gd name="csY0" fmla="*/ 94831 h 189220"/>
+                  <a:gd name="csX1" fmla="*/ 262647 w 623481"/>
+                  <a:gd name="csY1" fmla="*/ 797 h 189220"/>
+                  <a:gd name="csX2" fmla="*/ 623481 w 623481"/>
+                  <a:gd name="csY2" fmla="*/ 65276 h 189220"/>
+                  <a:gd name="csX3" fmla="*/ 262647 w 623481"/>
+                  <a:gd name="csY3" fmla="*/ 188865 h 189220"/>
+                  <a:gd name="csX4" fmla="*/ 0 w 623481"/>
+                  <a:gd name="csY4" fmla="*/ 94831 h 189220"/>
+                </a:gdLst>
+                <a:ahLst/>
+                <a:cxnLst>
+                  <a:cxn ang="0">
+                    <a:pos x="csX0" y="csY0"/>
+                  </a:cxn>
+                  <a:cxn ang="0">
+                    <a:pos x="csX1" y="csY1"/>
+                  </a:cxn>
+                  <a:cxn ang="0">
+                    <a:pos x="csX2" y="csY2"/>
+                  </a:cxn>
+                  <a:cxn ang="0">
+                    <a:pos x="csX3" y="csY3"/>
+                  </a:cxn>
+                  <a:cxn ang="0">
+                    <a:pos x="csX4" y="csY4"/>
+                  </a:cxn>
+                </a:cxnLst>
+                <a:rect l="l" t="t" r="r" b="b"/>
+                <a:pathLst>
+                  <a:path w="623481" h="189220">
+                    <a:moveTo>
+                      <a:pt x="0" y="94831"/>
+                    </a:moveTo>
+                    <a:cubicBezTo>
+                      <a:pt x="0" y="42897"/>
+                      <a:pt x="158734" y="5723"/>
+                      <a:pt x="262647" y="797"/>
+                    </a:cubicBezTo>
+                    <a:cubicBezTo>
+                      <a:pt x="366560" y="-4129"/>
+                      <a:pt x="623481" y="13342"/>
+                      <a:pt x="623481" y="65276"/>
+                    </a:cubicBezTo>
+                    <a:cubicBezTo>
+                      <a:pt x="623481" y="117210"/>
+                      <a:pt x="366560" y="183939"/>
+                      <a:pt x="262647" y="188865"/>
+                    </a:cubicBezTo>
+                    <a:cubicBezTo>
+                      <a:pt x="158734" y="193791"/>
+                      <a:pt x="0" y="146765"/>
+                      <a:pt x="0" y="94831"/>
+                    </a:cubicBezTo>
+                    <a:close/>
+                  </a:path>
+                </a:pathLst>
+              </a:custGeom>
+              <a:solidFill>
+                <a:schemeClr val="accent6">
+                  <a:lumMod val="75000"/>
+                </a:schemeClr>
+              </a:solidFill>
+              <a:ln>
+                <a:solidFill>
+                  <a:schemeClr val="accent6">
+                    <a:lumMod val="75000"/>
+                  </a:schemeClr>
+                </a:solidFill>
+              </a:ln>
+            </p:spPr>
+            <p:style>
+              <a:lnRef idx="2">
+                <a:schemeClr val="accent6">
+                  <a:shade val="15000"/>
+                </a:schemeClr>
+              </a:lnRef>
+              <a:fillRef idx="1">
+                <a:schemeClr val="accent6"/>
+              </a:fillRef>
+              <a:effectRef idx="0">
+                <a:schemeClr val="accent6"/>
+              </a:effectRef>
+              <a:fontRef idx="minor">
+                <a:schemeClr val="lt1"/>
+              </a:fontRef>
+            </p:style>
+            <p:txBody>
+              <a:bodyPr rtlCol="0" anchor="ctr"/>
+              <a:lstStyle/>
+              <a:p>
+                <a:pPr algn="ctr"/>
+                <a:endParaRPr lang="en-NZ"/>
+              </a:p>
+            </p:txBody>
+          </p:sp>
+          <p:sp>
+            <p:nvSpPr>
+              <p:cNvPr id="48" name="Oval 15">
+                <a:extLst>
+                  <a:ext uri="{FF2B5EF4-FFF2-40B4-BE49-F238E27FC236}">
+                    <a16:creationId xmlns:a16="http://schemas.microsoft.com/office/drawing/2014/main" id="{3F0B0211-B378-78E4-AA21-DBEFB02A27D9}"/>
+                  </a:ext>
+                </a:extLst>
+              </p:cNvPr>
+              <p:cNvSpPr/>
+              <p:nvPr/>
+            </p:nvSpPr>
+            <p:spPr>
+              <a:xfrm rot="2313172" flipH="1">
+                <a:off x="5906204" y="3935761"/>
+                <a:ext cx="368562" cy="86250"/>
+              </a:xfrm>
+              <a:custGeom>
+                <a:avLst/>
+                <a:gdLst>
+                  <a:gd name="csX0" fmla="*/ 0 w 525294"/>
+                  <a:gd name="csY0" fmla="*/ 94034 h 188068"/>
+                  <a:gd name="csX1" fmla="*/ 262647 w 525294"/>
+                  <a:gd name="csY1" fmla="*/ 0 h 188068"/>
+                  <a:gd name="csX2" fmla="*/ 525294 w 525294"/>
+                  <a:gd name="csY2" fmla="*/ 94034 h 188068"/>
+                  <a:gd name="csX3" fmla="*/ 262647 w 525294"/>
+                  <a:gd name="csY3" fmla="*/ 188068 h 188068"/>
+                  <a:gd name="csX4" fmla="*/ 0 w 525294"/>
+                  <a:gd name="csY4" fmla="*/ 94034 h 188068"/>
+                  <a:gd name="csX0" fmla="*/ 0 w 623481"/>
+                  <a:gd name="csY0" fmla="*/ 94831 h 189220"/>
+                  <a:gd name="csX1" fmla="*/ 262647 w 623481"/>
+                  <a:gd name="csY1" fmla="*/ 797 h 189220"/>
+                  <a:gd name="csX2" fmla="*/ 623481 w 623481"/>
+                  <a:gd name="csY2" fmla="*/ 65276 h 189220"/>
+                  <a:gd name="csX3" fmla="*/ 262647 w 623481"/>
+                  <a:gd name="csY3" fmla="*/ 188865 h 189220"/>
+                  <a:gd name="csX4" fmla="*/ 0 w 623481"/>
+                  <a:gd name="csY4" fmla="*/ 94831 h 189220"/>
+                </a:gdLst>
+                <a:ahLst/>
+                <a:cxnLst>
+                  <a:cxn ang="0">
+                    <a:pos x="csX0" y="csY0"/>
+                  </a:cxn>
+                  <a:cxn ang="0">
+                    <a:pos x="csX1" y="csY1"/>
+                  </a:cxn>
+                  <a:cxn ang="0">
+                    <a:pos x="csX2" y="csY2"/>
+                  </a:cxn>
+                  <a:cxn ang="0">
+                    <a:pos x="csX3" y="csY3"/>
+                  </a:cxn>
+                  <a:cxn ang="0">
+                    <a:pos x="csX4" y="csY4"/>
+                  </a:cxn>
+                </a:cxnLst>
+                <a:rect l="l" t="t" r="r" b="b"/>
+                <a:pathLst>
+                  <a:path w="623481" h="189220">
+                    <a:moveTo>
+                      <a:pt x="0" y="94831"/>
+                    </a:moveTo>
+                    <a:cubicBezTo>
+                      <a:pt x="0" y="42897"/>
+                      <a:pt x="158734" y="5723"/>
+                      <a:pt x="262647" y="797"/>
+                    </a:cubicBezTo>
+                    <a:cubicBezTo>
+                      <a:pt x="366560" y="-4129"/>
+                      <a:pt x="623481" y="13342"/>
+                      <a:pt x="623481" y="65276"/>
+                    </a:cubicBezTo>
+                    <a:cubicBezTo>
+                      <a:pt x="623481" y="117210"/>
+                      <a:pt x="366560" y="183939"/>
+                      <a:pt x="262647" y="188865"/>
+                    </a:cubicBezTo>
+                    <a:cubicBezTo>
+                      <a:pt x="158734" y="193791"/>
+                      <a:pt x="0" y="146765"/>
+                      <a:pt x="0" y="94831"/>
+                    </a:cubicBezTo>
+                    <a:close/>
+                  </a:path>
+                </a:pathLst>
+              </a:custGeom>
+              <a:solidFill>
+                <a:schemeClr val="accent6">
+                  <a:lumMod val="75000"/>
+                </a:schemeClr>
+              </a:solidFill>
+              <a:ln>
+                <a:solidFill>
+                  <a:schemeClr val="accent6">
+                    <a:lumMod val="75000"/>
+                  </a:schemeClr>
+                </a:solidFill>
+              </a:ln>
+            </p:spPr>
+            <p:style>
+              <a:lnRef idx="2">
+                <a:schemeClr val="accent6">
+                  <a:shade val="15000"/>
+                </a:schemeClr>
+              </a:lnRef>
+              <a:fillRef idx="1">
+                <a:schemeClr val="accent6"/>
+              </a:fillRef>
+              <a:effectRef idx="0">
+                <a:schemeClr val="accent6"/>
+              </a:effectRef>
+              <a:fontRef idx="minor">
+                <a:schemeClr val="lt1"/>
+              </a:fontRef>
+            </p:style>
+            <p:txBody>
+              <a:bodyPr rtlCol="0" anchor="ctr"/>
+              <a:lstStyle/>
+              <a:p>
+                <a:pPr algn="ctr"/>
+                <a:endParaRPr lang="en-NZ"/>
+              </a:p>
+            </p:txBody>
+          </p:sp>
+          <p:sp>
+            <p:nvSpPr>
+              <p:cNvPr id="49" name="Oval 15">
+                <a:extLst>
+                  <a:ext uri="{FF2B5EF4-FFF2-40B4-BE49-F238E27FC236}">
+                    <a16:creationId xmlns:a16="http://schemas.microsoft.com/office/drawing/2014/main" id="{3C367B3E-4DDC-8E0B-D8A5-178B65B3830A}"/>
+                  </a:ext>
+                </a:extLst>
+              </p:cNvPr>
+              <p:cNvSpPr/>
+              <p:nvPr/>
+            </p:nvSpPr>
+            <p:spPr>
+              <a:xfrm rot="2313172" flipH="1">
+                <a:off x="5988751" y="3323709"/>
+                <a:ext cx="291208" cy="92887"/>
+              </a:xfrm>
+              <a:custGeom>
+                <a:avLst/>
+                <a:gdLst>
+                  <a:gd name="csX0" fmla="*/ 0 w 525294"/>
+                  <a:gd name="csY0" fmla="*/ 94034 h 188068"/>
+                  <a:gd name="csX1" fmla="*/ 262647 w 525294"/>
+                  <a:gd name="csY1" fmla="*/ 0 h 188068"/>
+                  <a:gd name="csX2" fmla="*/ 525294 w 525294"/>
+                  <a:gd name="csY2" fmla="*/ 94034 h 188068"/>
+                  <a:gd name="csX3" fmla="*/ 262647 w 525294"/>
+                  <a:gd name="csY3" fmla="*/ 188068 h 188068"/>
+                  <a:gd name="csX4" fmla="*/ 0 w 525294"/>
+                  <a:gd name="csY4" fmla="*/ 94034 h 188068"/>
+                  <a:gd name="csX0" fmla="*/ 0 w 623481"/>
+                  <a:gd name="csY0" fmla="*/ 94831 h 189220"/>
+                  <a:gd name="csX1" fmla="*/ 262647 w 623481"/>
+                  <a:gd name="csY1" fmla="*/ 797 h 189220"/>
+                  <a:gd name="csX2" fmla="*/ 623481 w 623481"/>
+                  <a:gd name="csY2" fmla="*/ 65276 h 189220"/>
+                  <a:gd name="csX3" fmla="*/ 262647 w 623481"/>
+                  <a:gd name="csY3" fmla="*/ 188865 h 189220"/>
+                  <a:gd name="csX4" fmla="*/ 0 w 623481"/>
+                  <a:gd name="csY4" fmla="*/ 94831 h 189220"/>
+                </a:gdLst>
+                <a:ahLst/>
+                <a:cxnLst>
+                  <a:cxn ang="0">
+                    <a:pos x="csX0" y="csY0"/>
+                  </a:cxn>
+                  <a:cxn ang="0">
+                    <a:pos x="csX1" y="csY1"/>
+                  </a:cxn>
+                  <a:cxn ang="0">
+                    <a:pos x="csX2" y="csY2"/>
+                  </a:cxn>
+                  <a:cxn ang="0">
+                    <a:pos x="csX3" y="csY3"/>
+                  </a:cxn>
+                  <a:cxn ang="0">
+                    <a:pos x="csX4" y="csY4"/>
+                  </a:cxn>
+                </a:cxnLst>
+                <a:rect l="l" t="t" r="r" b="b"/>
+                <a:pathLst>
+                  <a:path w="623481" h="189220">
+                    <a:moveTo>
+                      <a:pt x="0" y="94831"/>
+                    </a:moveTo>
+                    <a:cubicBezTo>
+                      <a:pt x="0" y="42897"/>
+                      <a:pt x="158734" y="5723"/>
+                      <a:pt x="262647" y="797"/>
+                    </a:cubicBezTo>
+                    <a:cubicBezTo>
+                      <a:pt x="366560" y="-4129"/>
+                      <a:pt x="623481" y="13342"/>
+                      <a:pt x="623481" y="65276"/>
+                    </a:cubicBezTo>
+                    <a:cubicBezTo>
+                      <a:pt x="623481" y="117210"/>
+                      <a:pt x="366560" y="183939"/>
+                      <a:pt x="262647" y="188865"/>
+                    </a:cubicBezTo>
+                    <a:cubicBezTo>
+                      <a:pt x="158734" y="193791"/>
+                      <a:pt x="0" y="146765"/>
+                      <a:pt x="0" y="94831"/>
+                    </a:cubicBezTo>
+                    <a:close/>
+                  </a:path>
+                </a:pathLst>
+              </a:custGeom>
+              <a:solidFill>
+                <a:schemeClr val="accent6">
+                  <a:lumMod val="75000"/>
+                </a:schemeClr>
+              </a:solidFill>
+              <a:ln>
+                <a:solidFill>
+                  <a:schemeClr val="accent6">
+                    <a:lumMod val="75000"/>
+                  </a:schemeClr>
+                </a:solidFill>
+              </a:ln>
+            </p:spPr>
+            <p:style>
+              <a:lnRef idx="2">
+                <a:schemeClr val="accent6">
+                  <a:shade val="15000"/>
+                </a:schemeClr>
+              </a:lnRef>
+              <a:fillRef idx="1">
+                <a:schemeClr val="accent6"/>
+              </a:fillRef>
+              <a:effectRef idx="0">
+                <a:schemeClr val="accent6"/>
+              </a:effectRef>
+              <a:fontRef idx="minor">
+                <a:schemeClr val="lt1"/>
+              </a:fontRef>
+            </p:style>
+            <p:txBody>
+              <a:bodyPr rtlCol="0" anchor="ctr"/>
+              <a:lstStyle/>
+              <a:p>
+                <a:pPr algn="ctr"/>
+                <a:endParaRPr lang="en-NZ"/>
+              </a:p>
+            </p:txBody>
+          </p:sp>
+          <p:sp>
+            <p:nvSpPr>
+              <p:cNvPr id="50" name="Oval 15">
+                <a:extLst>
+                  <a:ext uri="{FF2B5EF4-FFF2-40B4-BE49-F238E27FC236}">
+                    <a16:creationId xmlns:a16="http://schemas.microsoft.com/office/drawing/2014/main" id="{B7262E78-04A3-D083-F6EA-59AA24828B8F}"/>
+                  </a:ext>
+                </a:extLst>
+              </p:cNvPr>
+              <p:cNvSpPr/>
+              <p:nvPr/>
+            </p:nvSpPr>
+            <p:spPr>
+              <a:xfrm rot="17214883">
+                <a:off x="6115209" y="3106268"/>
+                <a:ext cx="428121" cy="76467"/>
+              </a:xfrm>
+              <a:custGeom>
+                <a:avLst/>
+                <a:gdLst>
+                  <a:gd name="csX0" fmla="*/ 0 w 525294"/>
+                  <a:gd name="csY0" fmla="*/ 94034 h 188068"/>
+                  <a:gd name="csX1" fmla="*/ 262647 w 525294"/>
+                  <a:gd name="csY1" fmla="*/ 0 h 188068"/>
+                  <a:gd name="csX2" fmla="*/ 525294 w 525294"/>
+                  <a:gd name="csY2" fmla="*/ 94034 h 188068"/>
+                  <a:gd name="csX3" fmla="*/ 262647 w 525294"/>
+                  <a:gd name="csY3" fmla="*/ 188068 h 188068"/>
+                  <a:gd name="csX4" fmla="*/ 0 w 525294"/>
+                  <a:gd name="csY4" fmla="*/ 94034 h 188068"/>
+                  <a:gd name="csX0" fmla="*/ 0 w 623481"/>
+                  <a:gd name="csY0" fmla="*/ 94831 h 189220"/>
+                  <a:gd name="csX1" fmla="*/ 262647 w 623481"/>
+                  <a:gd name="csY1" fmla="*/ 797 h 189220"/>
+                  <a:gd name="csX2" fmla="*/ 623481 w 623481"/>
+                  <a:gd name="csY2" fmla="*/ 65276 h 189220"/>
+                  <a:gd name="csX3" fmla="*/ 262647 w 623481"/>
+                  <a:gd name="csY3" fmla="*/ 188865 h 189220"/>
+                  <a:gd name="csX4" fmla="*/ 0 w 623481"/>
+                  <a:gd name="csY4" fmla="*/ 94831 h 189220"/>
+                </a:gdLst>
+                <a:ahLst/>
+                <a:cxnLst>
+                  <a:cxn ang="0">
+                    <a:pos x="csX0" y="csY0"/>
+                  </a:cxn>
+                  <a:cxn ang="0">
+                    <a:pos x="csX1" y="csY1"/>
+                  </a:cxn>
+                  <a:cxn ang="0">
+                    <a:pos x="csX2" y="csY2"/>
+                  </a:cxn>
+                  <a:cxn ang="0">
+                    <a:pos x="csX3" y="csY3"/>
+                  </a:cxn>
+                  <a:cxn ang="0">
+                    <a:pos x="csX4" y="csY4"/>
+                  </a:cxn>
+                </a:cxnLst>
+                <a:rect l="l" t="t" r="r" b="b"/>
+                <a:pathLst>
+                  <a:path w="623481" h="189220">
+                    <a:moveTo>
+                      <a:pt x="0" y="94831"/>
+                    </a:moveTo>
+                    <a:cubicBezTo>
+                      <a:pt x="0" y="42897"/>
+                      <a:pt x="158734" y="5723"/>
+                      <a:pt x="262647" y="797"/>
+                    </a:cubicBezTo>
+                    <a:cubicBezTo>
+                      <a:pt x="366560" y="-4129"/>
+                      <a:pt x="623481" y="13342"/>
+                      <a:pt x="623481" y="65276"/>
+                    </a:cubicBezTo>
+                    <a:cubicBezTo>
+                      <a:pt x="623481" y="117210"/>
+                      <a:pt x="366560" y="183939"/>
+                      <a:pt x="262647" y="188865"/>
+                    </a:cubicBezTo>
+                    <a:cubicBezTo>
+                      <a:pt x="158734" y="193791"/>
+                      <a:pt x="0" y="146765"/>
+                      <a:pt x="0" y="94831"/>
+                    </a:cubicBezTo>
+                    <a:close/>
+                  </a:path>
+                </a:pathLst>
+              </a:custGeom>
+              <a:solidFill>
+                <a:schemeClr val="accent6">
+                  <a:lumMod val="75000"/>
+                </a:schemeClr>
+              </a:solidFill>
+              <a:ln>
+                <a:solidFill>
+                  <a:schemeClr val="accent6">
+                    <a:lumMod val="75000"/>
+                  </a:schemeClr>
+                </a:solidFill>
+              </a:ln>
+            </p:spPr>
+            <p:style>
+              <a:lnRef idx="2">
+                <a:schemeClr val="accent6">
+                  <a:shade val="15000"/>
+                </a:schemeClr>
+              </a:lnRef>
+              <a:fillRef idx="1">
+                <a:schemeClr val="accent6"/>
+              </a:fillRef>
+              <a:effectRef idx="0">
+                <a:schemeClr val="accent6"/>
+              </a:effectRef>
+              <a:fontRef idx="minor">
+                <a:schemeClr val="lt1"/>
+              </a:fontRef>
+            </p:style>
+            <p:txBody>
+              <a:bodyPr rtlCol="0" anchor="ctr"/>
+              <a:lstStyle/>
+              <a:p>
+                <a:pPr algn="ctr"/>
+                <a:endParaRPr lang="en-NZ"/>
+              </a:p>
+            </p:txBody>
+          </p:sp>
+          <p:sp>
+            <p:nvSpPr>
+              <p:cNvPr id="51" name="Freeform: Shape 50">
+                <a:extLst>
+                  <a:ext uri="{FF2B5EF4-FFF2-40B4-BE49-F238E27FC236}">
+                    <a16:creationId xmlns:a16="http://schemas.microsoft.com/office/drawing/2014/main" id="{7B9C2AAA-F11A-BDC2-FF63-3682DE58181C}"/>
+                  </a:ext>
+                </a:extLst>
+              </p:cNvPr>
+              <p:cNvSpPr/>
+              <p:nvPr/>
+            </p:nvSpPr>
+            <p:spPr>
+              <a:xfrm>
+                <a:off x="5799213" y="2487912"/>
+                <a:ext cx="477954" cy="2425430"/>
+              </a:xfrm>
+              <a:custGeom>
+                <a:avLst/>
+                <a:gdLst>
+                  <a:gd name="csX0" fmla="*/ 32425 w 477954"/>
+                  <a:gd name="csY0" fmla="*/ 0 h 2425430"/>
+                  <a:gd name="csX1" fmla="*/ 239949 w 477954"/>
+                  <a:gd name="csY1" fmla="*/ 272374 h 2425430"/>
+                  <a:gd name="csX2" fmla="*/ 453957 w 477954"/>
+                  <a:gd name="csY2" fmla="*/ 791183 h 2425430"/>
+                  <a:gd name="csX3" fmla="*/ 453957 w 477954"/>
+                  <a:gd name="csY3" fmla="*/ 1543455 h 2425430"/>
+                  <a:gd name="csX4" fmla="*/ 285344 w 477954"/>
+                  <a:gd name="csY4" fmla="*/ 2049293 h 2425430"/>
+                  <a:gd name="csX5" fmla="*/ 0 w 477954"/>
+                  <a:gd name="csY5" fmla="*/ 2425430 h 2425430"/>
+                  <a:gd name="csX6" fmla="*/ 0 w 477954"/>
+                  <a:gd name="csY6" fmla="*/ 2425430 h 2425430"/>
+                </a:gdLst>
+                <a:ahLst/>
+                <a:cxnLst>
+                  <a:cxn ang="0">
+                    <a:pos x="csX0" y="csY0"/>
+                  </a:cxn>
+                  <a:cxn ang="0">
+                    <a:pos x="csX1" y="csY1"/>
+                  </a:cxn>
+                  <a:cxn ang="0">
+                    <a:pos x="csX2" y="csY2"/>
+                  </a:cxn>
+                  <a:cxn ang="0">
+                    <a:pos x="csX3" y="csY3"/>
+                  </a:cxn>
+                  <a:cxn ang="0">
+                    <a:pos x="csX4" y="csY4"/>
+                  </a:cxn>
+                  <a:cxn ang="0">
+                    <a:pos x="csX5" y="csY5"/>
+                  </a:cxn>
+                  <a:cxn ang="0">
+                    <a:pos x="csX6" y="csY6"/>
+                  </a:cxn>
+                </a:cxnLst>
+                <a:rect l="l" t="t" r="r" b="b"/>
+                <a:pathLst>
+                  <a:path w="477954" h="2425430">
+                    <a:moveTo>
+                      <a:pt x="32425" y="0"/>
+                    </a:moveTo>
+                    <a:cubicBezTo>
+                      <a:pt x="101059" y="70255"/>
+                      <a:pt x="169694" y="140510"/>
+                      <a:pt x="239949" y="272374"/>
+                    </a:cubicBezTo>
+                    <a:cubicBezTo>
+                      <a:pt x="310204" y="404238"/>
+                      <a:pt x="418289" y="579336"/>
+                      <a:pt x="453957" y="791183"/>
+                    </a:cubicBezTo>
+                    <a:cubicBezTo>
+                      <a:pt x="489625" y="1003030"/>
+                      <a:pt x="482059" y="1333770"/>
+                      <a:pt x="453957" y="1543455"/>
+                    </a:cubicBezTo>
+                    <a:cubicBezTo>
+                      <a:pt x="425855" y="1753140"/>
+                      <a:pt x="361003" y="1902297"/>
+                      <a:pt x="285344" y="2049293"/>
+                    </a:cubicBezTo>
+                    <a:cubicBezTo>
+                      <a:pt x="209685" y="2196289"/>
+                      <a:pt x="0" y="2425430"/>
+                      <a:pt x="0" y="2425430"/>
+                    </a:cubicBezTo>
+                    <a:lnTo>
+                      <a:pt x="0" y="2425430"/>
+                    </a:lnTo>
+                  </a:path>
+                </a:pathLst>
+              </a:custGeom>
+              <a:noFill/>
+            </p:spPr>
+            <p:style>
+              <a:lnRef idx="2">
+                <a:schemeClr val="accent1">
+                  <a:shade val="15000"/>
+                </a:schemeClr>
+              </a:lnRef>
+              <a:fillRef idx="1">
+                <a:schemeClr val="accent1"/>
+              </a:fillRef>
+              <a:effectRef idx="0">
+                <a:schemeClr val="accent1"/>
+              </a:effectRef>
+              <a:fontRef idx="minor">
+                <a:schemeClr val="lt1"/>
+              </a:fontRef>
+            </p:style>
+            <p:txBody>
+              <a:bodyPr rtlCol="0" anchor="ctr"/>
+              <a:lstStyle/>
+              <a:p>
+                <a:pPr algn="ctr"/>
+                <a:endParaRPr lang="en-NZ"/>
+              </a:p>
+            </p:txBody>
+          </p:sp>
+          <p:sp>
+            <p:nvSpPr>
+              <p:cNvPr id="52" name="Oval 15">
+                <a:extLst>
+                  <a:ext uri="{FF2B5EF4-FFF2-40B4-BE49-F238E27FC236}">
+                    <a16:creationId xmlns:a16="http://schemas.microsoft.com/office/drawing/2014/main" id="{3FB89EA5-4934-BEED-5695-259919F057F0}"/>
+                  </a:ext>
+                </a:extLst>
+              </p:cNvPr>
+              <p:cNvSpPr/>
+              <p:nvPr/>
+            </p:nvSpPr>
+            <p:spPr>
+              <a:xfrm rot="1297676" flipH="1" flipV="1">
+                <a:off x="5798965" y="2887846"/>
+                <a:ext cx="336104" cy="74353"/>
+              </a:xfrm>
+              <a:custGeom>
+                <a:avLst/>
+                <a:gdLst>
+                  <a:gd name="csX0" fmla="*/ 0 w 525294"/>
+                  <a:gd name="csY0" fmla="*/ 94034 h 188068"/>
+                  <a:gd name="csX1" fmla="*/ 262647 w 525294"/>
+                  <a:gd name="csY1" fmla="*/ 0 h 188068"/>
+                  <a:gd name="csX2" fmla="*/ 525294 w 525294"/>
+                  <a:gd name="csY2" fmla="*/ 94034 h 188068"/>
+                  <a:gd name="csX3" fmla="*/ 262647 w 525294"/>
+                  <a:gd name="csY3" fmla="*/ 188068 h 188068"/>
+                  <a:gd name="csX4" fmla="*/ 0 w 525294"/>
+                  <a:gd name="csY4" fmla="*/ 94034 h 188068"/>
+                  <a:gd name="csX0" fmla="*/ 0 w 623481"/>
+                  <a:gd name="csY0" fmla="*/ 94831 h 189220"/>
+                  <a:gd name="csX1" fmla="*/ 262647 w 623481"/>
+                  <a:gd name="csY1" fmla="*/ 797 h 189220"/>
+                  <a:gd name="csX2" fmla="*/ 623481 w 623481"/>
+                  <a:gd name="csY2" fmla="*/ 65276 h 189220"/>
+                  <a:gd name="csX3" fmla="*/ 262647 w 623481"/>
+                  <a:gd name="csY3" fmla="*/ 188865 h 189220"/>
+                  <a:gd name="csX4" fmla="*/ 0 w 623481"/>
+                  <a:gd name="csY4" fmla="*/ 94831 h 189220"/>
+                </a:gdLst>
+                <a:ahLst/>
+                <a:cxnLst>
+                  <a:cxn ang="0">
+                    <a:pos x="csX0" y="csY0"/>
+                  </a:cxn>
+                  <a:cxn ang="0">
+                    <a:pos x="csX1" y="csY1"/>
+                  </a:cxn>
+                  <a:cxn ang="0">
+                    <a:pos x="csX2" y="csY2"/>
+                  </a:cxn>
+                  <a:cxn ang="0">
+                    <a:pos x="csX3" y="csY3"/>
+                  </a:cxn>
+                  <a:cxn ang="0">
+                    <a:pos x="csX4" y="csY4"/>
+                  </a:cxn>
+                </a:cxnLst>
+                <a:rect l="l" t="t" r="r" b="b"/>
+                <a:pathLst>
+                  <a:path w="623481" h="189220">
+                    <a:moveTo>
+                      <a:pt x="0" y="94831"/>
+                    </a:moveTo>
+                    <a:cubicBezTo>
+                      <a:pt x="0" y="42897"/>
+                      <a:pt x="158734" y="5723"/>
+                      <a:pt x="262647" y="797"/>
+                    </a:cubicBezTo>
+                    <a:cubicBezTo>
+                      <a:pt x="366560" y="-4129"/>
+                      <a:pt x="623481" y="13342"/>
+                      <a:pt x="623481" y="65276"/>
+                    </a:cubicBezTo>
+                    <a:cubicBezTo>
+                      <a:pt x="623481" y="117210"/>
+                      <a:pt x="366560" y="183939"/>
+                      <a:pt x="262647" y="188865"/>
+                    </a:cubicBezTo>
+                    <a:cubicBezTo>
+                      <a:pt x="158734" y="193791"/>
+                      <a:pt x="0" y="146765"/>
+                      <a:pt x="0" y="94831"/>
+                    </a:cubicBezTo>
+                    <a:close/>
+                  </a:path>
+                </a:pathLst>
+              </a:custGeom>
+              <a:solidFill>
+                <a:schemeClr val="accent6">
+                  <a:lumMod val="75000"/>
+                </a:schemeClr>
+              </a:solidFill>
+              <a:ln>
+                <a:solidFill>
+                  <a:schemeClr val="accent6">
+                    <a:lumMod val="75000"/>
+                  </a:schemeClr>
+                </a:solidFill>
+              </a:ln>
+            </p:spPr>
+            <p:style>
+              <a:lnRef idx="2">
+                <a:schemeClr val="accent6">
+                  <a:shade val="15000"/>
+                </a:schemeClr>
+              </a:lnRef>
+              <a:fillRef idx="1">
+                <a:schemeClr val="accent6"/>
+              </a:fillRef>
+              <a:effectRef idx="0">
+                <a:schemeClr val="accent6"/>
+              </a:effectRef>
+              <a:fontRef idx="minor">
+                <a:schemeClr val="lt1"/>
+              </a:fontRef>
+            </p:style>
+            <p:txBody>
+              <a:bodyPr rtlCol="0" anchor="ctr"/>
+              <a:lstStyle/>
+              <a:p>
+                <a:pPr algn="ctr"/>
+                <a:endParaRPr lang="en-NZ"/>
+              </a:p>
+            </p:txBody>
+          </p:sp>
+          <p:sp>
+            <p:nvSpPr>
+              <p:cNvPr id="53" name="Oval 15">
+                <a:extLst>
+                  <a:ext uri="{FF2B5EF4-FFF2-40B4-BE49-F238E27FC236}">
+                    <a16:creationId xmlns:a16="http://schemas.microsoft.com/office/drawing/2014/main" id="{9B0F7939-8C3C-1B47-56E5-FCD2E7320C1B}"/>
+                  </a:ext>
+                </a:extLst>
+              </p:cNvPr>
+              <p:cNvSpPr/>
+              <p:nvPr/>
+            </p:nvSpPr>
+            <p:spPr>
+              <a:xfrm rot="2313172" flipH="1">
+                <a:off x="5931238" y="3687580"/>
+                <a:ext cx="368562" cy="86250"/>
+              </a:xfrm>
+              <a:custGeom>
+                <a:avLst/>
+                <a:gdLst>
+                  <a:gd name="csX0" fmla="*/ 0 w 525294"/>
+                  <a:gd name="csY0" fmla="*/ 94034 h 188068"/>
+                  <a:gd name="csX1" fmla="*/ 262647 w 525294"/>
+                  <a:gd name="csY1" fmla="*/ 0 h 188068"/>
+                  <a:gd name="csX2" fmla="*/ 525294 w 525294"/>
+                  <a:gd name="csY2" fmla="*/ 94034 h 188068"/>
+                  <a:gd name="csX3" fmla="*/ 262647 w 525294"/>
+                  <a:gd name="csY3" fmla="*/ 188068 h 188068"/>
+                  <a:gd name="csX4" fmla="*/ 0 w 525294"/>
+                  <a:gd name="csY4" fmla="*/ 94034 h 188068"/>
+                  <a:gd name="csX0" fmla="*/ 0 w 623481"/>
+                  <a:gd name="csY0" fmla="*/ 94831 h 189220"/>
+                  <a:gd name="csX1" fmla="*/ 262647 w 623481"/>
+                  <a:gd name="csY1" fmla="*/ 797 h 189220"/>
+                  <a:gd name="csX2" fmla="*/ 623481 w 623481"/>
+                  <a:gd name="csY2" fmla="*/ 65276 h 189220"/>
+                  <a:gd name="csX3" fmla="*/ 262647 w 623481"/>
+                  <a:gd name="csY3" fmla="*/ 188865 h 189220"/>
+                  <a:gd name="csX4" fmla="*/ 0 w 623481"/>
+                  <a:gd name="csY4" fmla="*/ 94831 h 189220"/>
+                </a:gdLst>
+                <a:ahLst/>
+                <a:cxnLst>
+                  <a:cxn ang="0">
+                    <a:pos x="csX0" y="csY0"/>
+                  </a:cxn>
+                  <a:cxn ang="0">
+                    <a:pos x="csX1" y="csY1"/>
+                  </a:cxn>
+                  <a:cxn ang="0">
+                    <a:pos x="csX2" y="csY2"/>
+                  </a:cxn>
+                  <a:cxn ang="0">
+                    <a:pos x="csX3" y="csY3"/>
+                  </a:cxn>
+                  <a:cxn ang="0">
+                    <a:pos x="csX4" y="csY4"/>
+                  </a:cxn>
+                </a:cxnLst>
+                <a:rect l="l" t="t" r="r" b="b"/>
+                <a:pathLst>
+                  <a:path w="623481" h="189220">
+                    <a:moveTo>
+                      <a:pt x="0" y="94831"/>
+                    </a:moveTo>
+                    <a:cubicBezTo>
+                      <a:pt x="0" y="42897"/>
+                      <a:pt x="158734" y="5723"/>
+                      <a:pt x="262647" y="797"/>
+                    </a:cubicBezTo>
+                    <a:cubicBezTo>
+                      <a:pt x="366560" y="-4129"/>
+                      <a:pt x="623481" y="13342"/>
+                      <a:pt x="623481" y="65276"/>
+                    </a:cubicBezTo>
+                    <a:cubicBezTo>
+                      <a:pt x="623481" y="117210"/>
+                      <a:pt x="366560" y="183939"/>
+                      <a:pt x="262647" y="188865"/>
+                    </a:cubicBezTo>
+                    <a:cubicBezTo>
+                      <a:pt x="158734" y="193791"/>
+                      <a:pt x="0" y="146765"/>
+                      <a:pt x="0" y="94831"/>
+                    </a:cubicBezTo>
+                    <a:close/>
+                  </a:path>
+                </a:pathLst>
+              </a:custGeom>
+              <a:solidFill>
+                <a:schemeClr val="accent6">
+                  <a:lumMod val="75000"/>
+                </a:schemeClr>
+              </a:solidFill>
+              <a:ln>
+                <a:solidFill>
+                  <a:schemeClr val="accent6">
+                    <a:lumMod val="75000"/>
+                  </a:schemeClr>
+                </a:solidFill>
+              </a:ln>
+            </p:spPr>
+            <p:style>
+              <a:lnRef idx="2">
+                <a:schemeClr val="accent6">
+                  <a:shade val="15000"/>
+                </a:schemeClr>
+              </a:lnRef>
+              <a:fillRef idx="1">
+                <a:schemeClr val="accent6"/>
+              </a:fillRef>
+              <a:effectRef idx="0">
+                <a:schemeClr val="accent6"/>
+              </a:effectRef>
+              <a:fontRef idx="minor">
+                <a:schemeClr val="lt1"/>
+              </a:fontRef>
+            </p:style>
+            <p:txBody>
+              <a:bodyPr rtlCol="0" anchor="ctr"/>
+              <a:lstStyle/>
+              <a:p>
+                <a:pPr algn="ctr"/>
+                <a:endParaRPr lang="en-NZ"/>
+              </a:p>
+            </p:txBody>
+          </p:sp>
+          <p:sp>
+            <p:nvSpPr>
+              <p:cNvPr id="54" name="Oval 15">
+                <a:extLst>
+                  <a:ext uri="{FF2B5EF4-FFF2-40B4-BE49-F238E27FC236}">
+                    <a16:creationId xmlns:a16="http://schemas.microsoft.com/office/drawing/2014/main" id="{FF8475F1-258E-3369-589F-52CAC3091364}"/>
+                  </a:ext>
+                </a:extLst>
+              </p:cNvPr>
+              <p:cNvSpPr/>
+              <p:nvPr/>
+            </p:nvSpPr>
+            <p:spPr>
+              <a:xfrm rot="16599564">
+                <a:off x="5800619" y="2388447"/>
+                <a:ext cx="384004" cy="76570"/>
+              </a:xfrm>
+              <a:custGeom>
+                <a:avLst/>
+                <a:gdLst>
+                  <a:gd name="csX0" fmla="*/ 0 w 525294"/>
+                  <a:gd name="csY0" fmla="*/ 94034 h 188068"/>
+                  <a:gd name="csX1" fmla="*/ 262647 w 525294"/>
+                  <a:gd name="csY1" fmla="*/ 0 h 188068"/>
+                  <a:gd name="csX2" fmla="*/ 525294 w 525294"/>
+                  <a:gd name="csY2" fmla="*/ 94034 h 188068"/>
+                  <a:gd name="csX3" fmla="*/ 262647 w 525294"/>
+                  <a:gd name="csY3" fmla="*/ 188068 h 188068"/>
+                  <a:gd name="csX4" fmla="*/ 0 w 525294"/>
+                  <a:gd name="csY4" fmla="*/ 94034 h 188068"/>
+                  <a:gd name="csX0" fmla="*/ 0 w 623481"/>
+                  <a:gd name="csY0" fmla="*/ 94831 h 189220"/>
+                  <a:gd name="csX1" fmla="*/ 262647 w 623481"/>
+                  <a:gd name="csY1" fmla="*/ 797 h 189220"/>
+                  <a:gd name="csX2" fmla="*/ 623481 w 623481"/>
+                  <a:gd name="csY2" fmla="*/ 65276 h 189220"/>
+                  <a:gd name="csX3" fmla="*/ 262647 w 623481"/>
+                  <a:gd name="csY3" fmla="*/ 188865 h 189220"/>
+                  <a:gd name="csX4" fmla="*/ 0 w 623481"/>
+                  <a:gd name="csY4" fmla="*/ 94831 h 189220"/>
+                </a:gdLst>
+                <a:ahLst/>
+                <a:cxnLst>
+                  <a:cxn ang="0">
+                    <a:pos x="csX0" y="csY0"/>
+                  </a:cxn>
+                  <a:cxn ang="0">
+                    <a:pos x="csX1" y="csY1"/>
+                  </a:cxn>
+                  <a:cxn ang="0">
+                    <a:pos x="csX2" y="csY2"/>
+                  </a:cxn>
+                  <a:cxn ang="0">
+                    <a:pos x="csX3" y="csY3"/>
+                  </a:cxn>
+                  <a:cxn ang="0">
+                    <a:pos x="csX4" y="csY4"/>
+                  </a:cxn>
+                </a:cxnLst>
+                <a:rect l="l" t="t" r="r" b="b"/>
+                <a:pathLst>
+                  <a:path w="623481" h="189220">
+                    <a:moveTo>
+                      <a:pt x="0" y="94831"/>
+                    </a:moveTo>
+                    <a:cubicBezTo>
+                      <a:pt x="0" y="42897"/>
+                      <a:pt x="158734" y="5723"/>
+                      <a:pt x="262647" y="797"/>
+                    </a:cubicBezTo>
+                    <a:cubicBezTo>
+                      <a:pt x="366560" y="-4129"/>
+                      <a:pt x="623481" y="13342"/>
+                      <a:pt x="623481" y="65276"/>
+                    </a:cubicBezTo>
+                    <a:cubicBezTo>
+                      <a:pt x="623481" y="117210"/>
+                      <a:pt x="366560" y="183939"/>
+                      <a:pt x="262647" y="188865"/>
+                    </a:cubicBezTo>
+                    <a:cubicBezTo>
+                      <a:pt x="158734" y="193791"/>
+                      <a:pt x="0" y="146765"/>
+                      <a:pt x="0" y="94831"/>
+                    </a:cubicBezTo>
+                    <a:close/>
+                  </a:path>
+                </a:pathLst>
+              </a:custGeom>
+              <a:solidFill>
+                <a:schemeClr val="accent6">
+                  <a:lumMod val="75000"/>
+                </a:schemeClr>
+              </a:solidFill>
+              <a:ln>
+                <a:solidFill>
+                  <a:schemeClr val="accent6">
+                    <a:lumMod val="75000"/>
+                  </a:schemeClr>
+                </a:solidFill>
+              </a:ln>
+            </p:spPr>
+            <p:style>
+              <a:lnRef idx="2">
+                <a:schemeClr val="accent6">
+                  <a:shade val="15000"/>
+                </a:schemeClr>
+              </a:lnRef>
+              <a:fillRef idx="1">
+                <a:schemeClr val="accent6"/>
+              </a:fillRef>
+              <a:effectRef idx="0">
+                <a:schemeClr val="accent6"/>
+              </a:effectRef>
+              <a:fontRef idx="minor">
+                <a:schemeClr val="lt1"/>
+              </a:fontRef>
+            </p:style>
+            <p:txBody>
+              <a:bodyPr rtlCol="0" anchor="ctr"/>
+              <a:lstStyle/>
+              <a:p>
+                <a:pPr algn="ctr"/>
+                <a:endParaRPr lang="en-NZ"/>
+              </a:p>
+            </p:txBody>
+          </p:sp>
+          <p:sp>
+            <p:nvSpPr>
+              <p:cNvPr id="55" name="Oval 15">
+                <a:extLst>
+                  <a:ext uri="{FF2B5EF4-FFF2-40B4-BE49-F238E27FC236}">
+                    <a16:creationId xmlns:a16="http://schemas.microsoft.com/office/drawing/2014/main" id="{584BD3D6-B213-B8EC-F585-1AA9AFDF1D1D}"/>
+                  </a:ext>
+                </a:extLst>
+              </p:cNvPr>
+              <p:cNvSpPr/>
+              <p:nvPr/>
+            </p:nvSpPr>
+            <p:spPr>
+              <a:xfrm rot="17720721">
+                <a:off x="6162584" y="3440791"/>
+                <a:ext cx="428121" cy="76467"/>
+              </a:xfrm>
+              <a:custGeom>
+                <a:avLst/>
+                <a:gdLst>
+                  <a:gd name="csX0" fmla="*/ 0 w 525294"/>
+                  <a:gd name="csY0" fmla="*/ 94034 h 188068"/>
+                  <a:gd name="csX1" fmla="*/ 262647 w 525294"/>
+                  <a:gd name="csY1" fmla="*/ 0 h 188068"/>
+                  <a:gd name="csX2" fmla="*/ 525294 w 525294"/>
+                  <a:gd name="csY2" fmla="*/ 94034 h 188068"/>
+                  <a:gd name="csX3" fmla="*/ 262647 w 525294"/>
+                  <a:gd name="csY3" fmla="*/ 188068 h 188068"/>
+                  <a:gd name="csX4" fmla="*/ 0 w 525294"/>
+                  <a:gd name="csY4" fmla="*/ 94034 h 188068"/>
+                  <a:gd name="csX0" fmla="*/ 0 w 623481"/>
+                  <a:gd name="csY0" fmla="*/ 94831 h 189220"/>
+                  <a:gd name="csX1" fmla="*/ 262647 w 623481"/>
+                  <a:gd name="csY1" fmla="*/ 797 h 189220"/>
+                  <a:gd name="csX2" fmla="*/ 623481 w 623481"/>
+                  <a:gd name="csY2" fmla="*/ 65276 h 189220"/>
+                  <a:gd name="csX3" fmla="*/ 262647 w 623481"/>
+                  <a:gd name="csY3" fmla="*/ 188865 h 189220"/>
+                  <a:gd name="csX4" fmla="*/ 0 w 623481"/>
+                  <a:gd name="csY4" fmla="*/ 94831 h 189220"/>
+                </a:gdLst>
+                <a:ahLst/>
+                <a:cxnLst>
+                  <a:cxn ang="0">
+                    <a:pos x="csX0" y="csY0"/>
+                  </a:cxn>
+                  <a:cxn ang="0">
+                    <a:pos x="csX1" y="csY1"/>
+                  </a:cxn>
+                  <a:cxn ang="0">
+                    <a:pos x="csX2" y="csY2"/>
+                  </a:cxn>
+                  <a:cxn ang="0">
+                    <a:pos x="csX3" y="csY3"/>
+                  </a:cxn>
+                  <a:cxn ang="0">
+                    <a:pos x="csX4" y="csY4"/>
+                  </a:cxn>
+                </a:cxnLst>
+                <a:rect l="l" t="t" r="r" b="b"/>
+                <a:pathLst>
+                  <a:path w="623481" h="189220">
+                    <a:moveTo>
+                      <a:pt x="0" y="94831"/>
+                    </a:moveTo>
+                    <a:cubicBezTo>
+                      <a:pt x="0" y="42897"/>
+                      <a:pt x="158734" y="5723"/>
+                      <a:pt x="262647" y="797"/>
+                    </a:cubicBezTo>
+                    <a:cubicBezTo>
+                      <a:pt x="366560" y="-4129"/>
+                      <a:pt x="623481" y="13342"/>
+                      <a:pt x="623481" y="65276"/>
+                    </a:cubicBezTo>
+                    <a:cubicBezTo>
+                      <a:pt x="623481" y="117210"/>
+                      <a:pt x="366560" y="183939"/>
+                      <a:pt x="262647" y="188865"/>
+                    </a:cubicBezTo>
+                    <a:cubicBezTo>
+                      <a:pt x="158734" y="193791"/>
+                      <a:pt x="0" y="146765"/>
+                      <a:pt x="0" y="94831"/>
+                    </a:cubicBezTo>
+                    <a:close/>
+                  </a:path>
+                </a:pathLst>
+              </a:custGeom>
+              <a:solidFill>
+                <a:schemeClr val="accent6">
+                  <a:lumMod val="75000"/>
+                </a:schemeClr>
+              </a:solidFill>
+              <a:ln>
+                <a:solidFill>
+                  <a:schemeClr val="accent6">
+                    <a:lumMod val="75000"/>
+                  </a:schemeClr>
+                </a:solidFill>
+              </a:ln>
+            </p:spPr>
+            <p:style>
+              <a:lnRef idx="2">
+                <a:schemeClr val="accent6">
+                  <a:shade val="15000"/>
+                </a:schemeClr>
+              </a:lnRef>
+              <a:fillRef idx="1">
+                <a:schemeClr val="accent6"/>
+              </a:fillRef>
+              <a:effectRef idx="0">
+                <a:schemeClr val="accent6"/>
+              </a:effectRef>
+              <a:fontRef idx="minor">
+                <a:schemeClr val="lt1"/>
+              </a:fontRef>
+            </p:style>
+            <p:txBody>
+              <a:bodyPr rtlCol="0" anchor="ctr"/>
+              <a:lstStyle/>
+              <a:p>
+                <a:pPr algn="ctr"/>
+                <a:endParaRPr lang="en-NZ"/>
+              </a:p>
+            </p:txBody>
+          </p:sp>
+          <p:sp>
+            <p:nvSpPr>
+              <p:cNvPr id="56" name="Oval 15">
+                <a:extLst>
+                  <a:ext uri="{FF2B5EF4-FFF2-40B4-BE49-F238E27FC236}">
+                    <a16:creationId xmlns:a16="http://schemas.microsoft.com/office/drawing/2014/main" id="{04CA388B-D493-2A41-8CD7-17F6FB22EF6F}"/>
+                  </a:ext>
+                </a:extLst>
+              </p:cNvPr>
+              <p:cNvSpPr/>
+              <p:nvPr/>
+            </p:nvSpPr>
+            <p:spPr>
+              <a:xfrm rot="17826229">
+                <a:off x="6168485" y="3764374"/>
+                <a:ext cx="428121" cy="90431"/>
+              </a:xfrm>
+              <a:custGeom>
+                <a:avLst/>
+                <a:gdLst>
+                  <a:gd name="csX0" fmla="*/ 0 w 525294"/>
+                  <a:gd name="csY0" fmla="*/ 94034 h 188068"/>
+                  <a:gd name="csX1" fmla="*/ 262647 w 525294"/>
+                  <a:gd name="csY1" fmla="*/ 0 h 188068"/>
+                  <a:gd name="csX2" fmla="*/ 525294 w 525294"/>
+                  <a:gd name="csY2" fmla="*/ 94034 h 188068"/>
+                  <a:gd name="csX3" fmla="*/ 262647 w 525294"/>
+                  <a:gd name="csY3" fmla="*/ 188068 h 188068"/>
+                  <a:gd name="csX4" fmla="*/ 0 w 525294"/>
+                  <a:gd name="csY4" fmla="*/ 94034 h 188068"/>
+                  <a:gd name="csX0" fmla="*/ 0 w 623481"/>
+                  <a:gd name="csY0" fmla="*/ 94831 h 189220"/>
+                  <a:gd name="csX1" fmla="*/ 262647 w 623481"/>
+                  <a:gd name="csY1" fmla="*/ 797 h 189220"/>
+                  <a:gd name="csX2" fmla="*/ 623481 w 623481"/>
+                  <a:gd name="csY2" fmla="*/ 65276 h 189220"/>
+                  <a:gd name="csX3" fmla="*/ 262647 w 623481"/>
+                  <a:gd name="csY3" fmla="*/ 188865 h 189220"/>
+                  <a:gd name="csX4" fmla="*/ 0 w 623481"/>
+                  <a:gd name="csY4" fmla="*/ 94831 h 189220"/>
+                </a:gdLst>
+                <a:ahLst/>
+                <a:cxnLst>
+                  <a:cxn ang="0">
+                    <a:pos x="csX0" y="csY0"/>
+                  </a:cxn>
+                  <a:cxn ang="0">
+                    <a:pos x="csX1" y="csY1"/>
+                  </a:cxn>
+                  <a:cxn ang="0">
+                    <a:pos x="csX2" y="csY2"/>
+                  </a:cxn>
+                  <a:cxn ang="0">
+                    <a:pos x="csX3" y="csY3"/>
+                  </a:cxn>
+                  <a:cxn ang="0">
+                    <a:pos x="csX4" y="csY4"/>
+                  </a:cxn>
+                </a:cxnLst>
+                <a:rect l="l" t="t" r="r" b="b"/>
+                <a:pathLst>
+                  <a:path w="623481" h="189220">
+                    <a:moveTo>
+                      <a:pt x="0" y="94831"/>
+                    </a:moveTo>
+                    <a:cubicBezTo>
+                      <a:pt x="0" y="42897"/>
+                      <a:pt x="158734" y="5723"/>
+                      <a:pt x="262647" y="797"/>
+                    </a:cubicBezTo>
+                    <a:cubicBezTo>
+                      <a:pt x="366560" y="-4129"/>
+                      <a:pt x="623481" y="13342"/>
+                      <a:pt x="623481" y="65276"/>
+                    </a:cubicBezTo>
+                    <a:cubicBezTo>
+                      <a:pt x="623481" y="117210"/>
+                      <a:pt x="366560" y="183939"/>
+                      <a:pt x="262647" y="188865"/>
+                    </a:cubicBezTo>
+                    <a:cubicBezTo>
+                      <a:pt x="158734" y="193791"/>
+                      <a:pt x="0" y="146765"/>
+                      <a:pt x="0" y="94831"/>
+                    </a:cubicBezTo>
+                    <a:close/>
+                  </a:path>
+                </a:pathLst>
+              </a:custGeom>
+              <a:solidFill>
+                <a:schemeClr val="accent6">
+                  <a:lumMod val="75000"/>
+                </a:schemeClr>
+              </a:solidFill>
+              <a:ln>
+                <a:solidFill>
+                  <a:schemeClr val="accent6">
+                    <a:lumMod val="75000"/>
+                  </a:schemeClr>
+                </a:solidFill>
+              </a:ln>
+            </p:spPr>
+            <p:style>
+              <a:lnRef idx="2">
+                <a:schemeClr val="accent6">
+                  <a:shade val="15000"/>
+                </a:schemeClr>
+              </a:lnRef>
+              <a:fillRef idx="1">
+                <a:schemeClr val="accent6"/>
+              </a:fillRef>
+              <a:effectRef idx="0">
+                <a:schemeClr val="accent6"/>
+              </a:effectRef>
+              <a:fontRef idx="minor">
+                <a:schemeClr val="lt1"/>
+              </a:fontRef>
+            </p:style>
+            <p:txBody>
+              <a:bodyPr rtlCol="0" anchor="ctr"/>
+              <a:lstStyle/>
+              <a:p>
+                <a:pPr algn="ctr"/>
+                <a:endParaRPr lang="en-NZ"/>
+              </a:p>
+            </p:txBody>
+          </p:sp>
+        </p:grpSp>
+      </p:grpSp>
+    </p:spTree>
+    <p:extLst>
+      <p:ext uri="{BB962C8B-B14F-4D97-AF65-F5344CB8AC3E}">
+        <p14:creationId xmlns:p14="http://schemas.microsoft.com/office/powerpoint/2010/main" val="1275356749"/>
+      </p:ext>
+    </p:extLst>
+  </p:cSld>
+  <p:clrMapOvr>
+    <a:masterClrMapping/>
+  </p:clrMapOvr>
+</p:sld>
+</file>
+
+<file path=ppt/slides/slide3.xml><?xml version="1.0" encoding="utf-8"?>
+<p:sld xmlns:a="http://schemas.openxmlformats.org/drawingml/2006/main" xmlns:r="http://schemas.openxmlformats.org/officeDocument/2006/relationships" xmlns:p="http://schemas.openxmlformats.org/presentationml/2006/main">
+  <p:cSld>
+    <p:spTree>
+      <p:nvGrpSpPr>
+        <p:cNvPr id="1" name=""/>
+        <p:cNvGrpSpPr/>
+        <p:nvPr/>
+      </p:nvGrpSpPr>
+      <p:grpSpPr>
+        <a:xfrm>
+          <a:off x="0" y="0"/>
+          <a:ext cx="0" cy="0"/>
+          <a:chOff x="0" y="0"/>
+          <a:chExt cx="0" cy="0"/>
+        </a:xfrm>
+      </p:grpSpPr>
       <p:pic>
         <p:nvPicPr>
           <p:cNvPr id="5" name="Picture 4">
@@ -5997,7 +9681,7 @@
 </p:sld>
 </file>
 
-<file path=ppt/slides/slide3.xml><?xml version="1.0" encoding="utf-8"?>
+<file path=ppt/slides/slide4.xml><?xml version="1.0" encoding="utf-8"?>
 <p:sld xmlns:a="http://schemas.openxmlformats.org/drawingml/2006/main" xmlns:r="http://schemas.openxmlformats.org/officeDocument/2006/relationships" xmlns:p="http://schemas.openxmlformats.org/presentationml/2006/main">
   <p:cSld>
     <p:spTree>

</xml_diff>